<commit_message>
Fix slide 3 card overflow in real PowerPoint rendering
The browser preview sets lines tighter than PowerPoint does, so the
decision cards clipped their last line when opened for real. Verified by
exporting through PowerPoint and rasterising the PDF.

Co-Authored-By: Claude Opus 5 <noreply@anthropic.com>
</commit_message>
<xml_diff>
--- a/deck/bookly-agent-deck.pptx
+++ b/deck/bookly-agent-deck.pptx
@@ -5294,8 +5294,8 @@
         </p:nvSpPr>
         <p:spPr>
           <a:xfrm>
-            <a:off x="777240" y="2103120"/>
-            <a:ext cx="3301898" cy="3950208"/>
+            <a:off x="777240" y="1993392"/>
+            <a:ext cx="3301898" cy="4389120"/>
           </a:xfrm>
           <a:prstGeom prst="roundRect">
             <a:avLst>
@@ -5340,7 +5340,7 @@
         </p:nvSpPr>
         <p:spPr>
           <a:xfrm>
-            <a:off x="1051560" y="2340863"/>
+            <a:off x="1051560" y="2194560"/>
             <a:ext cx="914400" cy="384048"/>
           </a:xfrm>
           <a:prstGeom prst="rect">
@@ -5379,7 +5379,7 @@
         </p:nvSpPr>
         <p:spPr>
           <a:xfrm>
-            <a:off x="1051560" y="2761487"/>
+            <a:off x="1051560" y="2615184"/>
             <a:ext cx="2753258" cy="713232"/>
           </a:xfrm>
           <a:prstGeom prst="rect">
@@ -5434,8 +5434,8 @@
         </p:nvSpPr>
         <p:spPr>
           <a:xfrm>
-            <a:off x="1051560" y="3584448"/>
-            <a:ext cx="2753258" cy="658368"/>
+            <a:off x="1051560" y="3456432"/>
+            <a:ext cx="2753258" cy="713232"/>
           </a:xfrm>
           <a:prstGeom prst="rect">
             <a:avLst/>
@@ -5512,8 +5512,8 @@
         </p:nvSpPr>
         <p:spPr>
           <a:xfrm>
-            <a:off x="1051560" y="4572000"/>
-            <a:ext cx="2753258" cy="384048"/>
+            <a:off x="1051560" y="4590288"/>
+            <a:ext cx="2753258" cy="438912"/>
           </a:xfrm>
           <a:prstGeom prst="rect">
             <a:avLst/>
@@ -5551,7 +5551,7 @@
         </p:nvSpPr>
         <p:spPr>
           <a:xfrm>
-            <a:off x="1051560" y="4992624"/>
+            <a:off x="1051560" y="5230368"/>
             <a:ext cx="2753258" cy="219456"/>
           </a:xfrm>
           <a:prstGeom prst="rect">
@@ -5590,8 +5590,8 @@
         </p:nvSpPr>
         <p:spPr>
           <a:xfrm>
-            <a:off x="1051560" y="5230368"/>
-            <a:ext cx="2753258" cy="841248"/>
+            <a:off x="1051560" y="5486400"/>
+            <a:ext cx="2753258" cy="868680"/>
           </a:xfrm>
           <a:prstGeom prst="rect">
             <a:avLst/>
@@ -5629,8 +5629,8 @@
         </p:nvSpPr>
         <p:spPr>
           <a:xfrm>
-            <a:off x="4444898" y="2103120"/>
-            <a:ext cx="3301898" cy="3950208"/>
+            <a:off x="4444898" y="1993392"/>
+            <a:ext cx="3301898" cy="4389120"/>
           </a:xfrm>
           <a:prstGeom prst="roundRect">
             <a:avLst>
@@ -5675,7 +5675,7 @@
         </p:nvSpPr>
         <p:spPr>
           <a:xfrm>
-            <a:off x="4719218" y="2340863"/>
+            <a:off x="4719218" y="2194560"/>
             <a:ext cx="914400" cy="384048"/>
           </a:xfrm>
           <a:prstGeom prst="rect">
@@ -5714,7 +5714,7 @@
         </p:nvSpPr>
         <p:spPr>
           <a:xfrm>
-            <a:off x="4719218" y="2761487"/>
+            <a:off x="4719218" y="2615184"/>
             <a:ext cx="2753258" cy="713232"/>
           </a:xfrm>
           <a:prstGeom prst="rect">
@@ -5769,8 +5769,8 @@
         </p:nvSpPr>
         <p:spPr>
           <a:xfrm>
-            <a:off x="4719218" y="3584448"/>
-            <a:ext cx="2753258" cy="658368"/>
+            <a:off x="4719218" y="3456432"/>
+            <a:ext cx="2753258" cy="713232"/>
           </a:xfrm>
           <a:prstGeom prst="rect">
             <a:avLst/>
@@ -5847,8 +5847,8 @@
         </p:nvSpPr>
         <p:spPr>
           <a:xfrm>
-            <a:off x="4719218" y="4572000"/>
-            <a:ext cx="2753258" cy="384048"/>
+            <a:off x="4719218" y="4590288"/>
+            <a:ext cx="2753258" cy="438912"/>
           </a:xfrm>
           <a:prstGeom prst="rect">
             <a:avLst/>
@@ -5886,7 +5886,7 @@
         </p:nvSpPr>
         <p:spPr>
           <a:xfrm>
-            <a:off x="4719218" y="4992624"/>
+            <a:off x="4719218" y="5230368"/>
             <a:ext cx="2753258" cy="219456"/>
           </a:xfrm>
           <a:prstGeom prst="rect">
@@ -5925,8 +5925,8 @@
         </p:nvSpPr>
         <p:spPr>
           <a:xfrm>
-            <a:off x="4719218" y="5230368"/>
-            <a:ext cx="2753258" cy="841248"/>
+            <a:off x="4719218" y="5486400"/>
+            <a:ext cx="2753258" cy="868680"/>
           </a:xfrm>
           <a:prstGeom prst="rect">
             <a:avLst/>
@@ -5964,8 +5964,8 @@
         </p:nvSpPr>
         <p:spPr>
           <a:xfrm>
-            <a:off x="8112556" y="2103120"/>
-            <a:ext cx="3301898" cy="3950208"/>
+            <a:off x="8112556" y="1993392"/>
+            <a:ext cx="3301898" cy="4389120"/>
           </a:xfrm>
           <a:prstGeom prst="roundRect">
             <a:avLst>
@@ -6010,7 +6010,7 @@
         </p:nvSpPr>
         <p:spPr>
           <a:xfrm>
-            <a:off x="8386876" y="2340863"/>
+            <a:off x="8386876" y="2194560"/>
             <a:ext cx="914400" cy="384048"/>
           </a:xfrm>
           <a:prstGeom prst="rect">
@@ -6049,7 +6049,7 @@
         </p:nvSpPr>
         <p:spPr>
           <a:xfrm>
-            <a:off x="8386876" y="2761487"/>
+            <a:off x="8386876" y="2615184"/>
             <a:ext cx="2753258" cy="713232"/>
           </a:xfrm>
           <a:prstGeom prst="rect">
@@ -6104,8 +6104,8 @@
         </p:nvSpPr>
         <p:spPr>
           <a:xfrm>
-            <a:off x="8386876" y="3584448"/>
-            <a:ext cx="2753258" cy="658368"/>
+            <a:off x="8386876" y="3456432"/>
+            <a:ext cx="2753258" cy="713232"/>
           </a:xfrm>
           <a:prstGeom prst="rect">
             <a:avLst/>
@@ -6182,8 +6182,8 @@
         </p:nvSpPr>
         <p:spPr>
           <a:xfrm>
-            <a:off x="8386876" y="4572000"/>
-            <a:ext cx="2753258" cy="384048"/>
+            <a:off x="8386876" y="4590288"/>
+            <a:ext cx="2753258" cy="438912"/>
           </a:xfrm>
           <a:prstGeom prst="rect">
             <a:avLst/>
@@ -6221,7 +6221,7 @@
         </p:nvSpPr>
         <p:spPr>
           <a:xfrm>
-            <a:off x="8386876" y="4992624"/>
+            <a:off x="8386876" y="5230368"/>
             <a:ext cx="2753258" cy="219456"/>
           </a:xfrm>
           <a:prstGeom prst="rect">
@@ -6260,8 +6260,8 @@
         </p:nvSpPr>
         <p:spPr>
           <a:xfrm>
-            <a:off x="8386876" y="5230368"/>
-            <a:ext cx="2753258" cy="841248"/>
+            <a:off x="8386876" y="5486400"/>
+            <a:ext cx="2753258" cy="868680"/>
           </a:xfrm>
           <a:prstGeom prst="rect">
             <a:avLst/>

</xml_diff>

<commit_message>
Rebuild the deck for a talked-over video
The first deck was written to impress a reader who already knew how
agents work: twelve prose blocks on one slide, clever compressed
phrasing, assumed jargon. Wrong target - these slides get talked over in
a screen recording, and a deck the presenter cannot read fluently is
worse than a plain one.

- one idea per slide, headlines that carry the argument alone
- visible word count roughly halved; body text replaced by big type
- slide 4 redraws a real agent exchange as native shapes
- speaker notes rewritten as the actual script to say out loud
- DEMO.md restructured for slides-then-demo, with timings

Co-Authored-By: Claude Opus 5 <noreply@anthropic.com>
</commit_message>
<xml_diff>
--- a/deck/bookly-agent-deck.pptx
+++ b/deck/bookly-agent-deck.pptx
@@ -506,7 +506,13 @@
           <a:lstStyle/>
           <a:p>
             <a:r>
-              <a:t>The whole deck hangs off one sentence. Every design decision that follows is downstream of refusing to let the model be the authority on facts, permissions, or money.</a:t>
+              <a:t>SAY: "This is a customer support agent for Bookly, a fictional online bookstore. The whole thing is built on one idea, and it's on this slide: the AI writes the answer, but code makes the decision."</a:t>
+            </a:r>
+          </a:p>
+          <a:p/>
+          <a:p>
+            <a:r>
+              <a:t>Hold this slide for about five seconds. Don't explain it yet — the next slide explains why it matters.</a:t>
             </a:r>
           </a:p>
         </p:txBody>
@@ -576,7 +582,19 @@
           <a:lstStyle/>
           <a:p>
             <a:r>
-              <a:t>Walk left to right. The one thing to land: the tool layer is where the guardrails live, and policy.py is ordinary Python with no model in it. Memory is split -- the transcript is the model's, the verified facts are the application's.</a:t>
+              <a:t>SAY: "Here's the problem I designed around. If you ask an AI to bend a rule, it usually will — it's trained to be helpful. That's harmless when it's guessing a film recommendation. It's expensive when it's deciding whether to give someone their money back."</a:t>
+            </a:r>
+          </a:p>
+          <a:p/>
+          <a:p>
+            <a:r>
+              <a:t>"So I made a rule for myself: the model is never allowed to make that decision."</a:t>
+            </a:r>
+          </a:p>
+          <a:p/>
+          <a:p>
+            <a:r>
+              <a:t>About fifteen seconds.</a:t>
             </a:r>
           </a:p>
         </p:txBody>
@@ -646,7 +664,25 @@
           <a:lstStyle/>
           <a:p>
             <a:r>
-              <a:t>Do not read the cards. Pick decision 2 and tell the story: the customer who insists, the model that wants to please, and the four unit tests that make it not matter.</a:t>
+              <a:t>SAY: "Every single answer goes through the same three steps."</a:t>
+            </a:r>
+          </a:p>
+          <a:p/>
+          <a:p>
+            <a:r>
+              <a:t>"Claude reads the message and picks a tool. The tool is ordinary Python — it goes and gets the real answer. Then Claude puts that answer into friendly words."</a:t>
+            </a:r>
+          </a:p>
+          <a:p/>
+          <a:p>
+            <a:r>
+              <a:t>"Step two is the argument. Whether someone gets a refund is decided by a Python function with an if-statement in it. Forty-five days is more than thirty, so the answer is no — and there's no way to talk the model out of it, because the model was never asked."</a:t>
+            </a:r>
+          </a:p>
+          <a:p/>
+          <a:p>
+            <a:r>
+              <a:t>About twenty seconds. This is the slide that matters most.</a:t>
             </a:r>
           </a:p>
         </p:txBody>
@@ -716,7 +752,25 @@
           <a:lstStyle/>
           <a:p>
             <a:r>
-              <a:t>The brain-swap is the strongest evidence in the deck. Delete the API key and a dumb rule-based planner drives the same tools -- every guardrail still holds, because none of them were ever in the prompt.</a:t>
+              <a:t>SAY: "Here's what that looks like to a customer. This is a real exchange from the running agent."</a:t>
+            </a:r>
+          </a:p>
+          <a:p/>
+          <a:p>
+            <a:r>
+              <a:t>"The customer asks for a refund. Underneath, the agent looks the order up and calls the eligibility check, which comes back false. So it says no — warmly, with the reason, and it offers a human."</a:t>
+            </a:r>
+          </a:p>
+          <a:p/>
+          <a:p>
+            <a:r>
+              <a:t>"And if the customer pushes back and says 'come on, I'm a loyal customer' — it still says no. I tested that."</a:t>
+            </a:r>
+          </a:p>
+          <a:p/>
+          <a:p>
+            <a:r>
+              <a:t>About twenty seconds, then cut to the live demo.</a:t>
             </a:r>
           </a:p>
         </p:txBody>
@@ -786,7 +840,25 @@
           <a:lstStyle/>
           <a:p>
             <a:r>
-              <a:t>Close on the eval point -- it is the answer that separates people who have shipped an agent from people who have demoed one.</a:t>
+              <a:t>SAY: "Three things I'd do next. The first one isn't close."</a:t>
+            </a:r>
+          </a:p>
+          <a:p/>
+          <a:p>
+            <a:r>
+              <a:t>"The policy rules are covered by unit tests, so I know those are right. But nothing measures the model's half — did it pick the right tool, did it ask a question when it should have. Without an eval set, my next prompt change is a guess."</a:t>
+            </a:r>
+          </a:p>
+          <a:p/>
+          <a:p>
+            <a:r>
+              <a:t>Then close: "That's the agent. Let me show you it running."</a:t>
+            </a:r>
+          </a:p>
+          <a:p/>
+          <a:p>
+            <a:r>
+              <a:t>About fifteen seconds.</a:t>
             </a:r>
           </a:p>
         </p:txBody>
@@ -3808,8 +3880,8 @@
         </p:nvSpPr>
         <p:spPr>
           <a:xfrm>
-            <a:off x="777240" y="960120"/>
-            <a:ext cx="7315200" cy="274320"/>
+            <a:off x="868680" y="1188720"/>
+            <a:ext cx="7315200" cy="320040"/>
           </a:xfrm>
           <a:prstGeom prst="rect">
             <a:avLst/>
@@ -3824,17 +3896,17 @@
           <a:p>
             <a:pPr algn="l">
               <a:lnSpc>
-                <a:spcPct val="118000"/>
+                <a:spcPct val="120000"/>
               </a:lnSpc>
             </a:pPr>
             <a:r>
-              <a:rPr sz="1200" b="1" i="0">
+              <a:rPr sz="1300" b="1" i="0">
                 <a:solidFill>
                   <a:srgbClr val="8FB3A4"/>
                 </a:solidFill>
                 <a:latin typeface="Calibri"/>
               </a:rPr>
-              <a:t>BOOKLY  ·  SOLUTIONS ENGINEERING TAKE-HOME</a:t>
+              <a:t>BOOKLY  ·  CUSTOMER SUPPORT AGENT</a:t>
             </a:r>
           </a:p>
         </p:txBody>
@@ -3847,8 +3919,8 @@
         </p:nvSpPr>
         <p:spPr>
           <a:xfrm>
-            <a:off x="777240" y="1572768"/>
-            <a:ext cx="10241280" cy="2286000"/>
+            <a:off x="868680" y="1874519"/>
+            <a:ext cx="10424160" cy="2194560"/>
           </a:xfrm>
           <a:prstGeom prst="rect">
             <a:avLst/>
@@ -3863,33 +3935,33 @@
           <a:p>
             <a:pPr algn="l">
               <a:lnSpc>
-                <a:spcPct val="106000"/>
+                <a:spcPct val="110000"/>
               </a:lnSpc>
             </a:pPr>
             <a:r>
-              <a:rPr sz="5200" b="1" i="0">
+              <a:rPr sz="4600" b="1" i="0">
                 <a:solidFill>
                   <a:srgbClr val="FFFFFF"/>
                 </a:solidFill>
                 <a:latin typeface="Cambria"/>
               </a:rPr>
-              <a:t>The model should never</a:t>
+              <a:t>The AI writes the answer.</a:t>
             </a:r>
           </a:p>
           <a:p>
             <a:pPr algn="l">
               <a:lnSpc>
-                <a:spcPct val="106000"/>
+                <a:spcPct val="110000"/>
               </a:lnSpc>
             </a:pPr>
             <a:r>
-              <a:rPr sz="5200" b="1" i="0">
+              <a:rPr sz="4600" b="1" i="0">
                 <a:solidFill>
                   <a:srgbClr val="FFFFFF"/>
                 </a:solidFill>
                 <a:latin typeface="Cambria"/>
               </a:rPr>
-              <a:t>decide what's true.</a:t>
+              <a:t>Code makes the decision.</a:t>
             </a:r>
           </a:p>
         </p:txBody>
@@ -3902,8 +3974,8 @@
         </p:nvSpPr>
         <p:spPr>
           <a:xfrm>
-            <a:off x="777240" y="4041648"/>
-            <a:ext cx="1371600" cy="32004"/>
+            <a:off x="868680" y="4389120"/>
+            <a:ext cx="1463040" cy="36576"/>
           </a:xfrm>
           <a:prstGeom prst="rect">
             <a:avLst/>
@@ -3944,8 +4016,8 @@
         </p:nvSpPr>
         <p:spPr>
           <a:xfrm>
-            <a:off x="777240" y="4425696"/>
-            <a:ext cx="9052560" cy="1051560"/>
+            <a:off x="868680" y="5897880"/>
+            <a:ext cx="10424160" cy="384048"/>
           </a:xfrm>
           <a:prstGeom prst="rect">
             <a:avLst/>
@@ -3960,95 +4032,17 @@
           <a:p>
             <a:pPr algn="l">
               <a:lnSpc>
-                <a:spcPct val="132000"/>
+                <a:spcPct val="120000"/>
               </a:lnSpc>
             </a:pPr>
             <a:r>
-              <a:rPr sz="1700" b="0" i="0">
-                <a:solidFill>
-                  <a:srgbClr val="E8F0ED"/>
-                </a:solidFill>
-                <a:latin typeface="Calibri"/>
-              </a:rPr>
-              <a:t>A customer support agent for Bookly, built so that language understanding and business authority are deliberately different parts of the system.</a:t>
-            </a:r>
-          </a:p>
-        </p:txBody>
-      </p:sp>
-      <p:sp>
-        <p:nvSpPr>
-          <p:cNvPr id="6" name="TextBox 5"/>
-          <p:cNvSpPr txBox="1"/>
-          <p:nvPr/>
-        </p:nvSpPr>
-        <p:spPr>
-          <a:xfrm>
-            <a:off x="777240" y="5989320"/>
-            <a:ext cx="5486400" cy="292608"/>
-          </a:xfrm>
-          <a:prstGeom prst="rect">
-            <a:avLst/>
-          </a:prstGeom>
-          <a:noFill/>
-        </p:spPr>
-        <p:txBody>
-          <a:bodyPr wrap="square" lIns="0" rIns="0" tIns="0" bIns="0" anchor="t">
-            <a:spAutoFit/>
-          </a:bodyPr>
-          <a:lstStyle/>
-          <a:p>
-            <a:pPr algn="l">
-              <a:lnSpc>
-                <a:spcPct val="118000"/>
-              </a:lnSpc>
-            </a:pPr>
-            <a:r>
-              <a:rPr sz="1250" b="0" i="0">
+              <a:rPr sz="1350" b="0" i="0">
                 <a:solidFill>
                   <a:srgbClr val="9DAAA3"/>
                 </a:solidFill>
                 <a:latin typeface="Calibri"/>
               </a:rPr>
               <a:t>Seyfullah Ural   ·   September 2026</a:t>
-            </a:r>
-          </a:p>
-        </p:txBody>
-      </p:sp>
-      <p:sp>
-        <p:nvSpPr>
-          <p:cNvPr id="7" name="TextBox 6"/>
-          <p:cNvSpPr txBox="1"/>
-          <p:nvPr/>
-        </p:nvSpPr>
-        <p:spPr>
-          <a:xfrm>
-            <a:off x="6400800" y="5989320"/>
-            <a:ext cx="5010912" cy="292608"/>
-          </a:xfrm>
-          <a:prstGeom prst="rect">
-            <a:avLst/>
-          </a:prstGeom>
-          <a:noFill/>
-        </p:spPr>
-        <p:txBody>
-          <a:bodyPr wrap="square" lIns="0" rIns="0" tIns="0" bIns="0" anchor="t">
-            <a:spAutoFit/>
-          </a:bodyPr>
-          <a:lstStyle/>
-          <a:p>
-            <a:pPr algn="r">
-              <a:lnSpc>
-                <a:spcPct val="118000"/>
-              </a:lnSpc>
-            </a:pPr>
-            <a:r>
-              <a:rPr sz="1250" b="0" i="0">
-                <a:solidFill>
-                  <a:srgbClr val="9DAAA3"/>
-                </a:solidFill>
-                <a:latin typeface="Calibri"/>
-              </a:rPr>
-              <a:t>Python  ·  Anthropic API  ·  no agent framework</a:t>
             </a:r>
           </a:p>
         </p:txBody>
@@ -4087,8 +4081,8 @@
         </p:nvSpPr>
         <p:spPr>
           <a:xfrm>
-            <a:off x="777240" y="658368"/>
-            <a:ext cx="9601200" cy="566928"/>
+            <a:off x="868680" y="868680"/>
+            <a:ext cx="10241280" cy="1554480"/>
           </a:xfrm>
           <a:prstGeom prst="rect">
             <a:avLst/>
@@ -4103,83 +4097,58 @@
           <a:p>
             <a:pPr algn="l">
               <a:lnSpc>
-                <a:spcPct val="118000"/>
+                <a:spcPct val="110000"/>
               </a:lnSpc>
             </a:pPr>
             <a:r>
-              <a:rPr sz="3500" b="1" i="0">
+              <a:rPr sz="4200" b="1" i="0">
                 <a:solidFill>
                   <a:srgbClr val="14201C"/>
                 </a:solidFill>
                 <a:latin typeface="Cambria"/>
               </a:rPr>
-              <a:t>How a question becomes an answer</a:t>
-            </a:r>
-          </a:p>
-        </p:txBody>
-      </p:sp>
-      <p:sp>
-        <p:nvSpPr>
-          <p:cNvPr id="3" name="TextBox 2"/>
-          <p:cNvSpPr txBox="1"/>
-          <p:nvPr/>
-        </p:nvSpPr>
-        <p:spPr>
-          <a:xfrm>
-            <a:off x="777240" y="1316736"/>
-            <a:ext cx="10332720" cy="365760"/>
-          </a:xfrm>
-          <a:prstGeom prst="rect">
-            <a:avLst/>
-          </a:prstGeom>
-          <a:noFill/>
-        </p:spPr>
-        <p:txBody>
-          <a:bodyPr wrap="square" lIns="0" rIns="0" tIns="0" bIns="0" anchor="t">
-            <a:spAutoFit/>
-          </a:bodyPr>
-          <a:lstStyle/>
+              <a:t>An AI wants to please you.</a:t>
+            </a:r>
+          </a:p>
           <a:p>
             <a:pPr algn="l">
               <a:lnSpc>
-                <a:spcPct val="118000"/>
+                <a:spcPct val="110000"/>
               </a:lnSpc>
             </a:pPr>
             <a:r>
-              <a:rPr sz="1600" b="0" i="0">
+              <a:rPr sz="4200" b="1" i="0">
                 <a:solidFill>
-                  <a:srgbClr val="6E7671"/>
+                  <a:srgbClr val="14201C"/>
                 </a:solidFill>
-                <a:latin typeface="Calibri"/>
+                <a:latin typeface="Cambria"/>
               </a:rPr>
-              <a:t>Four components, and only the first one is probabilistic.</a:t>
-            </a:r>
-          </a:p>
-        </p:txBody>
-      </p:sp>
-      <p:sp>
-        <p:nvSpPr>
-          <p:cNvPr id="4" name="Rounded Rectangle 3"/>
+              <a:t>A refund policy shouldn't.</a:t>
+            </a:r>
+          </a:p>
+        </p:txBody>
+      </p:sp>
+      <p:sp>
+        <p:nvSpPr>
+          <p:cNvPr id="3" name="Rounded Rectangle 2"/>
           <p:cNvSpPr/>
           <p:nvPr/>
         </p:nvSpPr>
         <p:spPr>
           <a:xfrm>
-            <a:off x="777240" y="2395728"/>
-            <a:ext cx="2395728" cy="1481328"/>
+            <a:off x="868680" y="3246120"/>
+            <a:ext cx="5074920" cy="1874519"/>
           </a:xfrm>
           <a:prstGeom prst="roundRect">
             <a:avLst>
-              <a:gd name="adj" fmla="val 5555"/>
+              <a:gd name="adj" fmla="val 4878"/>
             </a:avLst>
           </a:prstGeom>
           <a:solidFill>
-            <a:srgbClr val="FFFFFF"/>
+            <a:srgbClr val="F5E7DE"/>
           </a:solidFill>
-          <a:ln w="12700">
-            <a:solidFill>
-              <a:srgbClr val="DEDDD8"/>
-            </a:solidFill>
+          <a:ln>
+            <a:noFill/>
           </a:ln>
           <a:effectLst/>
         </p:spPr>
@@ -4205,14 +4174,14 @@
       </p:sp>
       <p:sp>
         <p:nvSpPr>
-          <p:cNvPr id="5" name="TextBox 4"/>
+          <p:cNvPr id="4" name="TextBox 3"/>
           <p:cNvSpPr txBox="1"/>
           <p:nvPr/>
         </p:nvSpPr>
         <p:spPr>
           <a:xfrm>
-            <a:off x="996695" y="2596896"/>
-            <a:ext cx="1956816" cy="274320"/>
+            <a:off x="1234440" y="3520440"/>
+            <a:ext cx="4343400" cy="292608"/>
           </a:xfrm>
           <a:prstGeom prst="rect">
             <a:avLst/>
@@ -4227,31 +4196,31 @@
           <a:p>
             <a:pPr algn="l">
               <a:lnSpc>
-                <a:spcPct val="118000"/>
+                <a:spcPct val="120000"/>
               </a:lnSpc>
             </a:pPr>
             <a:r>
-              <a:rPr sz="1100" b="1" i="0">
+              <a:rPr sz="1200" b="1" i="0">
                 <a:solidFill>
-                  <a:srgbClr val="8FB3A4"/>
+                  <a:srgbClr val="A4552B"/>
                 </a:solidFill>
                 <a:latin typeface="Calibri"/>
               </a:rPr>
-              <a:t>PROMPTS</a:t>
-            </a:r>
-          </a:p>
-        </p:txBody>
-      </p:sp>
-      <p:sp>
-        <p:nvSpPr>
-          <p:cNvPr id="6" name="TextBox 5"/>
+              <a:t>A CHATBOT OPTIMISES FOR</a:t>
+            </a:r>
+          </a:p>
+        </p:txBody>
+      </p:sp>
+      <p:sp>
+        <p:nvSpPr>
+          <p:cNvPr id="5" name="TextBox 4"/>
           <p:cNvSpPr txBox="1"/>
           <p:nvPr/>
         </p:nvSpPr>
         <p:spPr>
           <a:xfrm>
-            <a:off x="996695" y="2926080"/>
-            <a:ext cx="1956816" cy="310896"/>
+            <a:off x="1234440" y="3931920"/>
+            <a:ext cx="4343400" cy="960120"/>
           </a:xfrm>
           <a:prstGeom prst="rect">
             <a:avLst/>
@@ -4266,94 +4235,55 @@
           <a:p>
             <a:pPr algn="l">
               <a:lnSpc>
-                <a:spcPct val="118000"/>
+                <a:spcPct val="115000"/>
               </a:lnSpc>
             </a:pPr>
             <a:r>
-              <a:rPr sz="1650" b="1" i="0">
+              <a:rPr sz="2500" b="1" i="0">
                 <a:solidFill>
                   <a:srgbClr val="14201C"/>
                 </a:solidFill>
-                <a:latin typeface="Calibri"/>
+                <a:latin typeface="Cambria"/>
               </a:rPr>
-              <a:t>System prompt</a:t>
-            </a:r>
-          </a:p>
-        </p:txBody>
-      </p:sp>
-      <p:sp>
-        <p:nvSpPr>
-          <p:cNvPr id="7" name="TextBox 6"/>
-          <p:cNvSpPr txBox="1"/>
-          <p:nvPr/>
-        </p:nvSpPr>
-        <p:spPr>
-          <a:xfrm>
-            <a:off x="996695" y="3264408"/>
-            <a:ext cx="1956816" cy="548640"/>
-          </a:xfrm>
-          <a:prstGeom prst="rect">
-            <a:avLst/>
-          </a:prstGeom>
-          <a:noFill/>
-        </p:spPr>
-        <p:txBody>
-          <a:bodyPr wrap="square" lIns="0" rIns="0" tIns="0" bIns="0" anchor="t">
-            <a:spAutoFit/>
-          </a:bodyPr>
-          <a:lstStyle/>
+              <a:t>Making you happy</a:t>
+            </a:r>
+          </a:p>
           <a:p>
             <a:pPr algn="l">
               <a:lnSpc>
-                <a:spcPct val="125000"/>
+                <a:spcPct val="115000"/>
               </a:lnSpc>
             </a:pPr>
             <a:r>
-              <a:rPr sz="1250" b="0" i="0">
+              <a:rPr sz="2500" b="1" i="0">
                 <a:solidFill>
-                  <a:srgbClr val="6E7671"/>
+                  <a:srgbClr val="14201C"/>
                 </a:solidFill>
-                <a:latin typeface="Calibri"/>
+                <a:latin typeface="Cambria"/>
               </a:rPr>
-              <a:t>Tone and judgement only.</a:t>
-            </a:r>
-          </a:p>
-          <a:p>
-            <a:pPr algn="l">
-              <a:lnSpc>
-                <a:spcPct val="125000"/>
-              </a:lnSpc>
-            </a:pPr>
-            <a:r>
-              <a:rPr sz="1250" b="0" i="0">
-                <a:solidFill>
-                  <a:srgbClr val="6E7671"/>
-                </a:solidFill>
-                <a:latin typeface="Calibri"/>
-              </a:rPr>
-              <a:t>No business rules.</a:t>
-            </a:r>
-          </a:p>
-        </p:txBody>
-      </p:sp>
-      <p:sp>
-        <p:nvSpPr>
-          <p:cNvPr id="8" name="Rounded Rectangle 7"/>
+              <a:t>right now.</a:t>
+            </a:r>
+          </a:p>
+        </p:txBody>
+      </p:sp>
+      <p:sp>
+        <p:nvSpPr>
+          <p:cNvPr id="6" name="Rounded Rectangle 5"/>
           <p:cNvSpPr/>
           <p:nvPr/>
         </p:nvSpPr>
         <p:spPr>
           <a:xfrm>
-            <a:off x="3557016" y="2395728"/>
-            <a:ext cx="2395728" cy="1481328"/>
+            <a:off x="6428232" y="3246120"/>
+            <a:ext cx="5074920" cy="1874519"/>
           </a:xfrm>
           <a:prstGeom prst="roundRect">
             <a:avLst>
-              <a:gd name="adj" fmla="val 5555"/>
+              <a:gd name="adj" fmla="val 4878"/>
             </a:avLst>
           </a:prstGeom>
           <a:solidFill>
-            <a:srgbClr val="1F5F4F"/>
+            <a:srgbClr val="E8F0ED"/>
           </a:solidFill>
           <a:ln>
             <a:noFill/>
@@ -4382,14 +4312,14 @@
       </p:sp>
       <p:sp>
         <p:nvSpPr>
-          <p:cNvPr id="9" name="TextBox 8"/>
+          <p:cNvPr id="7" name="TextBox 6"/>
           <p:cNvSpPr txBox="1"/>
           <p:nvPr/>
         </p:nvSpPr>
         <p:spPr>
           <a:xfrm>
-            <a:off x="3776472" y="2596896"/>
-            <a:ext cx="1956816" cy="274320"/>
+            <a:off x="6793992" y="3520440"/>
+            <a:ext cx="4343400" cy="292608"/>
           </a:xfrm>
           <a:prstGeom prst="rect">
             <a:avLst/>
@@ -4404,31 +4334,31 @@
           <a:p>
             <a:pPr algn="l">
               <a:lnSpc>
-                <a:spcPct val="118000"/>
+                <a:spcPct val="120000"/>
               </a:lnSpc>
             </a:pPr>
             <a:r>
-              <a:rPr sz="1100" b="1" i="0">
+              <a:rPr sz="1200" b="1" i="0">
                 <a:solidFill>
-                  <a:srgbClr val="8FB3A4"/>
+                  <a:srgbClr val="1F5F4F"/>
                 </a:solidFill>
                 <a:latin typeface="Calibri"/>
               </a:rPr>
-              <a:t>ORCHESTRATION</a:t>
-            </a:r>
-          </a:p>
-        </p:txBody>
-      </p:sp>
-      <p:sp>
-        <p:nvSpPr>
-          <p:cNvPr id="10" name="TextBox 9"/>
+              <a:t>A SUPPORT AGENT MUST OPTIMISE FOR</a:t>
+            </a:r>
+          </a:p>
+        </p:txBody>
+      </p:sp>
+      <p:sp>
+        <p:nvSpPr>
+          <p:cNvPr id="8" name="TextBox 7"/>
           <p:cNvSpPr txBox="1"/>
           <p:nvPr/>
         </p:nvSpPr>
         <p:spPr>
           <a:xfrm>
-            <a:off x="3776472" y="2926080"/>
-            <a:ext cx="1956816" cy="310896"/>
+            <a:off x="6793992" y="3931920"/>
+            <a:ext cx="4343400" cy="960120"/>
           </a:xfrm>
           <a:prstGeom prst="rect">
             <a:avLst/>
@@ -4443,31 +4373,47 @@
           <a:p>
             <a:pPr algn="l">
               <a:lnSpc>
-                <a:spcPct val="118000"/>
+                <a:spcPct val="115000"/>
               </a:lnSpc>
             </a:pPr>
             <a:r>
-              <a:rPr sz="1650" b="1" i="0">
+              <a:rPr sz="2500" b="1" i="0">
                 <a:solidFill>
-                  <a:srgbClr val="FFFFFF"/>
+                  <a:srgbClr val="14201C"/>
                 </a:solidFill>
-                <a:latin typeface="Calibri"/>
+                <a:latin typeface="Cambria"/>
               </a:rPr>
-              <a:t>Agent loop</a:t>
-            </a:r>
-          </a:p>
-        </p:txBody>
-      </p:sp>
-      <p:sp>
-        <p:nvSpPr>
-          <p:cNvPr id="11" name="TextBox 10"/>
+              <a:t>Being right</a:t>
+            </a:r>
+          </a:p>
+          <a:p>
+            <a:pPr algn="l">
+              <a:lnSpc>
+                <a:spcPct val="115000"/>
+              </a:lnSpc>
+            </a:pPr>
+            <a:r>
+              <a:rPr sz="2500" b="1" i="0">
+                <a:solidFill>
+                  <a:srgbClr val="14201C"/>
+                </a:solidFill>
+                <a:latin typeface="Cambria"/>
+              </a:rPr>
+              <a:t>about money.</a:t>
+            </a:r>
+          </a:p>
+        </p:txBody>
+      </p:sp>
+      <p:sp>
+        <p:nvSpPr>
+          <p:cNvPr id="9" name="TextBox 8"/>
           <p:cNvSpPr txBox="1"/>
           <p:nvPr/>
         </p:nvSpPr>
         <p:spPr>
           <a:xfrm>
-            <a:off x="3776472" y="3264408"/>
-            <a:ext cx="1956816" cy="548640"/>
+            <a:off x="868680" y="5669280"/>
+            <a:ext cx="10424160" cy="411480"/>
           </a:xfrm>
           <a:prstGeom prst="rect">
             <a:avLst/>
@@ -4482,702 +4428,17 @@
           <a:p>
             <a:pPr algn="l">
               <a:lnSpc>
-                <a:spcPct val="125000"/>
+                <a:spcPct val="120000"/>
               </a:lnSpc>
             </a:pPr>
             <a:r>
-              <a:rPr sz="1250" b="0" i="0">
-                <a:solidFill>
-                  <a:srgbClr val="E8F0ED"/>
-                </a:solidFill>
-                <a:latin typeface="Calibri"/>
-              </a:rPr>
-              <a:t>Hand-written, ~60 lines.</a:t>
-            </a:r>
-          </a:p>
-          <a:p>
-            <a:pPr algn="l">
-              <a:lnSpc>
-                <a:spcPct val="125000"/>
-              </a:lnSpc>
-            </a:pPr>
-            <a:r>
-              <a:rPr sz="1250" b="0" i="0">
-                <a:solidFill>
-                  <a:srgbClr val="E8F0ED"/>
-                </a:solidFill>
-                <a:latin typeface="Calibri"/>
-              </a:rPr>
-              <a:t>Iteration cap, full trace.</a:t>
-            </a:r>
-          </a:p>
-        </p:txBody>
-      </p:sp>
-      <p:sp>
-        <p:nvSpPr>
-          <p:cNvPr id="12" name="Rounded Rectangle 11"/>
-          <p:cNvSpPr/>
-          <p:nvPr/>
-        </p:nvSpPr>
-        <p:spPr>
-          <a:xfrm>
-            <a:off x="6336792" y="2395728"/>
-            <a:ext cx="2395728" cy="1481328"/>
-          </a:xfrm>
-          <a:prstGeom prst="roundRect">
-            <a:avLst>
-              <a:gd name="adj" fmla="val 5555"/>
-            </a:avLst>
-          </a:prstGeom>
-          <a:solidFill>
-            <a:srgbClr val="FFFFFF"/>
-          </a:solidFill>
-          <a:ln w="12700">
-            <a:solidFill>
-              <a:srgbClr val="DEDDD8"/>
-            </a:solidFill>
-          </a:ln>
-          <a:effectLst/>
-        </p:spPr>
-        <p:style>
-          <a:lnRef idx="1">
-            <a:schemeClr val="accent1"/>
-          </a:lnRef>
-          <a:fillRef idx="3">
-            <a:schemeClr val="accent1"/>
-          </a:fillRef>
-          <a:effectRef idx="2">
-            <a:schemeClr val="accent1"/>
-          </a:effectRef>
-          <a:fontRef idx="minor">
-            <a:schemeClr val="lt1"/>
-          </a:fontRef>
-        </p:style>
-        <p:txBody>
-          <a:bodyPr rtlCol="0" anchor="ctr"/>
-          <a:lstStyle/>
-          <a:p/>
-        </p:txBody>
-      </p:sp>
-      <p:sp>
-        <p:nvSpPr>
-          <p:cNvPr id="13" name="TextBox 12"/>
-          <p:cNvSpPr txBox="1"/>
-          <p:nvPr/>
-        </p:nvSpPr>
-        <p:spPr>
-          <a:xfrm>
-            <a:off x="6556248" y="2596896"/>
-            <a:ext cx="1956816" cy="274320"/>
-          </a:xfrm>
-          <a:prstGeom prst="rect">
-            <a:avLst/>
-          </a:prstGeom>
-          <a:noFill/>
-        </p:spPr>
-        <p:txBody>
-          <a:bodyPr wrap="square" lIns="0" rIns="0" tIns="0" bIns="0" anchor="t">
-            <a:spAutoFit/>
-          </a:bodyPr>
-          <a:lstStyle/>
-          <a:p>
-            <a:pPr algn="l">
-              <a:lnSpc>
-                <a:spcPct val="118000"/>
-              </a:lnSpc>
-            </a:pPr>
-            <a:r>
-              <a:rPr sz="1100" b="1" i="0">
-                <a:solidFill>
-                  <a:srgbClr val="8FB3A4"/>
-                </a:solidFill>
-                <a:latin typeface="Calibri"/>
-              </a:rPr>
-              <a:t>TOOLS</a:t>
-            </a:r>
-          </a:p>
-        </p:txBody>
-      </p:sp>
-      <p:sp>
-        <p:nvSpPr>
-          <p:cNvPr id="14" name="TextBox 13"/>
-          <p:cNvSpPr txBox="1"/>
-          <p:nvPr/>
-        </p:nvSpPr>
-        <p:spPr>
-          <a:xfrm>
-            <a:off x="6556248" y="2926080"/>
-            <a:ext cx="1956816" cy="310896"/>
-          </a:xfrm>
-          <a:prstGeom prst="rect">
-            <a:avLst/>
-          </a:prstGeom>
-          <a:noFill/>
-        </p:spPr>
-        <p:txBody>
-          <a:bodyPr wrap="square" lIns="0" rIns="0" tIns="0" bIns="0" anchor="t">
-            <a:spAutoFit/>
-          </a:bodyPr>
-          <a:lstStyle/>
-          <a:p>
-            <a:pPr algn="l">
-              <a:lnSpc>
-                <a:spcPct val="118000"/>
-              </a:lnSpc>
-            </a:pPr>
-            <a:r>
-              <a:rPr sz="1650" b="1" i="0">
-                <a:solidFill>
-                  <a:srgbClr val="14201C"/>
-                </a:solidFill>
-                <a:latin typeface="Calibri"/>
-              </a:rPr>
-              <a:t>Tool layer</a:t>
-            </a:r>
-          </a:p>
-        </p:txBody>
-      </p:sp>
-      <p:sp>
-        <p:nvSpPr>
-          <p:cNvPr id="15" name="TextBox 14"/>
-          <p:cNvSpPr txBox="1"/>
-          <p:nvPr/>
-        </p:nvSpPr>
-        <p:spPr>
-          <a:xfrm>
-            <a:off x="6556248" y="3264408"/>
-            <a:ext cx="1956816" cy="548640"/>
-          </a:xfrm>
-          <a:prstGeom prst="rect">
-            <a:avLst/>
-          </a:prstGeom>
-          <a:noFill/>
-        </p:spPr>
-        <p:txBody>
-          <a:bodyPr wrap="square" lIns="0" rIns="0" tIns="0" bIns="0" anchor="t">
-            <a:spAutoFit/>
-          </a:bodyPr>
-          <a:lstStyle/>
-          <a:p>
-            <a:pPr algn="l">
-              <a:lnSpc>
-                <a:spcPct val="125000"/>
-              </a:lnSpc>
-            </a:pPr>
-            <a:r>
-              <a:rPr sz="1250" b="0" i="0">
+              <a:rPr sz="1700" b="0" i="1">
                 <a:solidFill>
                   <a:srgbClr val="6E7671"/>
                 </a:solidFill>
                 <a:latin typeface="Calibri"/>
               </a:rPr>
-              <a:t>Identity checks and refund</a:t>
-            </a:r>
-          </a:p>
-          <a:p>
-            <a:pPr algn="l">
-              <a:lnSpc>
-                <a:spcPct val="125000"/>
-              </a:lnSpc>
-            </a:pPr>
-            <a:r>
-              <a:rPr sz="1250" b="0" i="0">
-                <a:solidFill>
-                  <a:srgbClr val="6E7671"/>
-                </a:solidFill>
-                <a:latin typeface="Calibri"/>
-              </a:rPr>
-              <a:t>preconditions live here.</a:t>
-            </a:r>
-          </a:p>
-        </p:txBody>
-      </p:sp>
-      <p:sp>
-        <p:nvSpPr>
-          <p:cNvPr id="16" name="Rounded Rectangle 15"/>
-          <p:cNvSpPr/>
-          <p:nvPr/>
-        </p:nvSpPr>
-        <p:spPr>
-          <a:xfrm>
-            <a:off x="9116568" y="2395728"/>
-            <a:ext cx="2395728" cy="1481328"/>
-          </a:xfrm>
-          <a:prstGeom prst="roundRect">
-            <a:avLst>
-              <a:gd name="adj" fmla="val 5555"/>
-            </a:avLst>
-          </a:prstGeom>
-          <a:solidFill>
-            <a:srgbClr val="FFFFFF"/>
-          </a:solidFill>
-          <a:ln w="12700">
-            <a:solidFill>
-              <a:srgbClr val="DEDDD8"/>
-            </a:solidFill>
-          </a:ln>
-          <a:effectLst/>
-        </p:spPr>
-        <p:style>
-          <a:lnRef idx="1">
-            <a:schemeClr val="accent1"/>
-          </a:lnRef>
-          <a:fillRef idx="3">
-            <a:schemeClr val="accent1"/>
-          </a:fillRef>
-          <a:effectRef idx="2">
-            <a:schemeClr val="accent1"/>
-          </a:effectRef>
-          <a:fontRef idx="minor">
-            <a:schemeClr val="lt1"/>
-          </a:fontRef>
-        </p:style>
-        <p:txBody>
-          <a:bodyPr rtlCol="0" anchor="ctr"/>
-          <a:lstStyle/>
-          <a:p/>
-        </p:txBody>
-      </p:sp>
-      <p:sp>
-        <p:nvSpPr>
-          <p:cNvPr id="17" name="TextBox 16"/>
-          <p:cNvSpPr txBox="1"/>
-          <p:nvPr/>
-        </p:nvSpPr>
-        <p:spPr>
-          <a:xfrm>
-            <a:off x="9336024" y="2596896"/>
-            <a:ext cx="1956816" cy="274320"/>
-          </a:xfrm>
-          <a:prstGeom prst="rect">
-            <a:avLst/>
-          </a:prstGeom>
-          <a:noFill/>
-        </p:spPr>
-        <p:txBody>
-          <a:bodyPr wrap="square" lIns="0" rIns="0" tIns="0" bIns="0" anchor="t">
-            <a:spAutoFit/>
-          </a:bodyPr>
-          <a:lstStyle/>
-          <a:p>
-            <a:pPr algn="l">
-              <a:lnSpc>
-                <a:spcPct val="118000"/>
-              </a:lnSpc>
-            </a:pPr>
-            <a:r>
-              <a:rPr sz="1100" b="1" i="0">
-                <a:solidFill>
-                  <a:srgbClr val="8FB3A4"/>
-                </a:solidFill>
-                <a:latin typeface="Calibri"/>
-              </a:rPr>
-              <a:t>MEMORY</a:t>
-            </a:r>
-          </a:p>
-        </p:txBody>
-      </p:sp>
-      <p:sp>
-        <p:nvSpPr>
-          <p:cNvPr id="18" name="TextBox 17"/>
-          <p:cNvSpPr txBox="1"/>
-          <p:nvPr/>
-        </p:nvSpPr>
-        <p:spPr>
-          <a:xfrm>
-            <a:off x="9336024" y="2926080"/>
-            <a:ext cx="1956816" cy="310896"/>
-          </a:xfrm>
-          <a:prstGeom prst="rect">
-            <a:avLst/>
-          </a:prstGeom>
-          <a:noFill/>
-        </p:spPr>
-        <p:txBody>
-          <a:bodyPr wrap="square" lIns="0" rIns="0" tIns="0" bIns="0" anchor="t">
-            <a:spAutoFit/>
-          </a:bodyPr>
-          <a:lstStyle/>
-          <a:p>
-            <a:pPr algn="l">
-              <a:lnSpc>
-                <a:spcPct val="118000"/>
-              </a:lnSpc>
-            </a:pPr>
-            <a:r>
-              <a:rPr sz="1650" b="1" i="0">
-                <a:solidFill>
-                  <a:srgbClr val="14201C"/>
-                </a:solidFill>
-                <a:latin typeface="Calibri"/>
-              </a:rPr>
-              <a:t>Split state</a:t>
-            </a:r>
-          </a:p>
-        </p:txBody>
-      </p:sp>
-      <p:sp>
-        <p:nvSpPr>
-          <p:cNvPr id="19" name="TextBox 18"/>
-          <p:cNvSpPr txBox="1"/>
-          <p:nvPr/>
-        </p:nvSpPr>
-        <p:spPr>
-          <a:xfrm>
-            <a:off x="9336024" y="3264408"/>
-            <a:ext cx="1956816" cy="548640"/>
-          </a:xfrm>
-          <a:prstGeom prst="rect">
-            <a:avLst/>
-          </a:prstGeom>
-          <a:noFill/>
-        </p:spPr>
-        <p:txBody>
-          <a:bodyPr wrap="square" lIns="0" rIns="0" tIns="0" bIns="0" anchor="t">
-            <a:spAutoFit/>
-          </a:bodyPr>
-          <a:lstStyle/>
-          <a:p>
-            <a:pPr algn="l">
-              <a:lnSpc>
-                <a:spcPct val="125000"/>
-              </a:lnSpc>
-            </a:pPr>
-            <a:r>
-              <a:rPr sz="1250" b="0" i="0">
-                <a:solidFill>
-                  <a:srgbClr val="6E7671"/>
-                </a:solidFill>
-                <a:latin typeface="Calibri"/>
-              </a:rPr>
-              <a:t>Transcript for the model.</a:t>
-            </a:r>
-          </a:p>
-          <a:p>
-            <a:pPr algn="l">
-              <a:lnSpc>
-                <a:spcPct val="125000"/>
-              </a:lnSpc>
-            </a:pPr>
-            <a:r>
-              <a:rPr sz="1250" b="0" i="0">
-                <a:solidFill>
-                  <a:srgbClr val="6E7671"/>
-                </a:solidFill>
-                <a:latin typeface="Calibri"/>
-              </a:rPr>
-              <a:t>Verified facts for the app.</a:t>
-            </a:r>
-          </a:p>
-        </p:txBody>
-      </p:sp>
-      <p:sp>
-        <p:nvSpPr>
-          <p:cNvPr id="20" name="Right Arrow 19"/>
-          <p:cNvSpPr/>
-          <p:nvPr/>
-        </p:nvSpPr>
-        <p:spPr>
-          <a:xfrm>
-            <a:off x="3264408" y="3067812"/>
-            <a:ext cx="201167" cy="137160"/>
-          </a:xfrm>
-          <a:prstGeom prst="rightArrow">
-            <a:avLst/>
-          </a:prstGeom>
-          <a:solidFill>
-            <a:srgbClr val="8FB3A4"/>
-          </a:solidFill>
-          <a:ln>
-            <a:noFill/>
-          </a:ln>
-          <a:effectLst/>
-        </p:spPr>
-        <p:style>
-          <a:lnRef idx="1">
-            <a:schemeClr val="accent1"/>
-          </a:lnRef>
-          <a:fillRef idx="3">
-            <a:schemeClr val="accent1"/>
-          </a:fillRef>
-          <a:effectRef idx="2">
-            <a:schemeClr val="accent1"/>
-          </a:effectRef>
-          <a:fontRef idx="minor">
-            <a:schemeClr val="lt1"/>
-          </a:fontRef>
-        </p:style>
-        <p:txBody>
-          <a:bodyPr rtlCol="0" anchor="ctr"/>
-          <a:lstStyle/>
-          <a:p>
-            <a:pPr algn="ctr"/>
-          </a:p>
-        </p:txBody>
-      </p:sp>
-      <p:sp>
-        <p:nvSpPr>
-          <p:cNvPr id="21" name="Right Arrow 20"/>
-          <p:cNvSpPr/>
-          <p:nvPr/>
-        </p:nvSpPr>
-        <p:spPr>
-          <a:xfrm>
-            <a:off x="6044183" y="3067812"/>
-            <a:ext cx="201167" cy="137160"/>
-          </a:xfrm>
-          <a:prstGeom prst="rightArrow">
-            <a:avLst/>
-          </a:prstGeom>
-          <a:solidFill>
-            <a:srgbClr val="8FB3A4"/>
-          </a:solidFill>
-          <a:ln>
-            <a:noFill/>
-          </a:ln>
-          <a:effectLst/>
-        </p:spPr>
-        <p:style>
-          <a:lnRef idx="1">
-            <a:schemeClr val="accent1"/>
-          </a:lnRef>
-          <a:fillRef idx="3">
-            <a:schemeClr val="accent1"/>
-          </a:fillRef>
-          <a:effectRef idx="2">
-            <a:schemeClr val="accent1"/>
-          </a:effectRef>
-          <a:fontRef idx="minor">
-            <a:schemeClr val="lt1"/>
-          </a:fontRef>
-        </p:style>
-        <p:txBody>
-          <a:bodyPr rtlCol="0" anchor="ctr"/>
-          <a:lstStyle/>
-          <a:p>
-            <a:pPr algn="ctr"/>
-          </a:p>
-        </p:txBody>
-      </p:sp>
-      <p:sp>
-        <p:nvSpPr>
-          <p:cNvPr id="22" name="Right Arrow 21"/>
-          <p:cNvSpPr/>
-          <p:nvPr/>
-        </p:nvSpPr>
-        <p:spPr>
-          <a:xfrm>
-            <a:off x="8823960" y="3067812"/>
-            <a:ext cx="201167" cy="137160"/>
-          </a:xfrm>
-          <a:prstGeom prst="rightArrow">
-            <a:avLst/>
-          </a:prstGeom>
-          <a:solidFill>
-            <a:srgbClr val="8FB3A4"/>
-          </a:solidFill>
-          <a:ln>
-            <a:noFill/>
-          </a:ln>
-          <a:effectLst/>
-        </p:spPr>
-        <p:style>
-          <a:lnRef idx="1">
-            <a:schemeClr val="accent1"/>
-          </a:lnRef>
-          <a:fillRef idx="3">
-            <a:schemeClr val="accent1"/>
-          </a:fillRef>
-          <a:effectRef idx="2">
-            <a:schemeClr val="accent1"/>
-          </a:effectRef>
-          <a:fontRef idx="minor">
-            <a:schemeClr val="lt1"/>
-          </a:fontRef>
-        </p:style>
-        <p:txBody>
-          <a:bodyPr rtlCol="0" anchor="ctr"/>
-          <a:lstStyle/>
-          <a:p>
-            <a:pPr algn="ctr"/>
-          </a:p>
-        </p:txBody>
-      </p:sp>
-      <p:sp>
-        <p:nvSpPr>
-          <p:cNvPr id="23" name="Rounded Rectangle 22"/>
-          <p:cNvSpPr/>
-          <p:nvPr/>
-        </p:nvSpPr>
-        <p:spPr>
-          <a:xfrm>
-            <a:off x="777240" y="4480560"/>
-            <a:ext cx="10634472" cy="1298448"/>
-          </a:xfrm>
-          <a:prstGeom prst="roundRect">
-            <a:avLst>
-              <a:gd name="adj" fmla="val 6338"/>
-            </a:avLst>
-          </a:prstGeom>
-          <a:solidFill>
-            <a:srgbClr val="E8F0ED"/>
-          </a:solidFill>
-          <a:ln>
-            <a:noFill/>
-          </a:ln>
-          <a:effectLst/>
-        </p:spPr>
-        <p:style>
-          <a:lnRef idx="1">
-            <a:schemeClr val="accent1"/>
-          </a:lnRef>
-          <a:fillRef idx="3">
-            <a:schemeClr val="accent1"/>
-          </a:fillRef>
-          <a:effectRef idx="2">
-            <a:schemeClr val="accent1"/>
-          </a:effectRef>
-          <a:fontRef idx="minor">
-            <a:schemeClr val="lt1"/>
-          </a:fontRef>
-        </p:style>
-        <p:txBody>
-          <a:bodyPr rtlCol="0" anchor="ctr"/>
-          <a:lstStyle/>
-          <a:p/>
-        </p:txBody>
-      </p:sp>
-      <p:sp>
-        <p:nvSpPr>
-          <p:cNvPr id="24" name="TextBox 23"/>
-          <p:cNvSpPr txBox="1"/>
-          <p:nvPr/>
-        </p:nvSpPr>
-        <p:spPr>
-          <a:xfrm>
-            <a:off x="1088136" y="4681728"/>
-            <a:ext cx="3200400" cy="292608"/>
-          </a:xfrm>
-          <a:prstGeom prst="rect">
-            <a:avLst/>
-          </a:prstGeom>
-          <a:noFill/>
-        </p:spPr>
-        <p:txBody>
-          <a:bodyPr wrap="square" lIns="0" rIns="0" tIns="0" bIns="0" anchor="t">
-            <a:spAutoFit/>
-          </a:bodyPr>
-          <a:lstStyle/>
-          <a:p>
-            <a:pPr algn="l">
-              <a:lnSpc>
-                <a:spcPct val="118000"/>
-              </a:lnSpc>
-            </a:pPr>
-            <a:r>
-              <a:rPr sz="1100" b="1" i="0">
-                <a:solidFill>
-                  <a:srgbClr val="1F5F4F"/>
-                </a:solidFill>
-                <a:latin typeface="Calibri"/>
-              </a:rPr>
-              <a:t>THE LOAD-BEARING PART</a:t>
-            </a:r>
-          </a:p>
-        </p:txBody>
-      </p:sp>
-      <p:sp>
-        <p:nvSpPr>
-          <p:cNvPr id="25" name="TextBox 24"/>
-          <p:cNvSpPr txBox="1"/>
-          <p:nvPr/>
-        </p:nvSpPr>
-        <p:spPr>
-          <a:xfrm>
-            <a:off x="1088136" y="5029200"/>
-            <a:ext cx="10012680" cy="658368"/>
-          </a:xfrm>
-          <a:prstGeom prst="rect">
-            <a:avLst/>
-          </a:prstGeom>
-          <a:noFill/>
-        </p:spPr>
-        <p:txBody>
-          <a:bodyPr wrap="square" lIns="0" rIns="0" tIns="0" bIns="0" anchor="t">
-            <a:spAutoFit/>
-          </a:bodyPr>
-          <a:lstStyle/>
-          <a:p>
-            <a:pPr algn="l">
-              <a:lnSpc>
-                <a:spcPct val="130000"/>
-              </a:lnSpc>
-            </a:pPr>
-            <a:r>
-              <a:rPr sz="1500" b="1" i="0">
-                <a:solidFill>
-                  <a:srgbClr val="1F5F4F"/>
-                </a:solidFill>
-                <a:latin typeface="Courier New"/>
-              </a:rPr>
-              <a:t>check_return_eligibility</a:t>
-            </a:r>
-            <a:r>
-              <a:rPr sz="1500" b="0" i="0">
-                <a:solidFill>
-                  <a:srgbClr val="14201C"/>
-                </a:solidFill>
-                <a:latin typeface="Calibri"/>
-              </a:rPr>
-              <a:t> is ordinary Python. No model, no prompt, no temperature. It is the only authority on whether something can be returned — and the agent is not permitted to contradict it.</a:t>
-            </a:r>
-          </a:p>
-        </p:txBody>
-      </p:sp>
-      <p:sp>
-        <p:nvSpPr>
-          <p:cNvPr id="26" name="TextBox 25"/>
-          <p:cNvSpPr txBox="1"/>
-          <p:nvPr/>
-        </p:nvSpPr>
-        <p:spPr>
-          <a:xfrm>
-            <a:off x="777240" y="6053328"/>
-            <a:ext cx="10634472" cy="384048"/>
-          </a:xfrm>
-          <a:prstGeom prst="rect">
-            <a:avLst/>
-          </a:prstGeom>
-          <a:noFill/>
-        </p:spPr>
-        <p:txBody>
-          <a:bodyPr wrap="square" lIns="0" rIns="0" tIns="0" bIns="0" anchor="t">
-            <a:spAutoFit/>
-          </a:bodyPr>
-          <a:lstStyle/>
-          <a:p>
-            <a:pPr algn="l">
-              <a:lnSpc>
-                <a:spcPct val="118000"/>
-              </a:lnSpc>
-            </a:pPr>
-            <a:r>
-              <a:rPr sz="1300" b="1" i="0">
-                <a:solidFill>
-                  <a:srgbClr val="6E7671"/>
-                </a:solidFill>
-                <a:latin typeface="Calibri"/>
-              </a:rPr>
-              <a:t>The core knows nothing about HTTP. </a:t>
-            </a:r>
-            <a:r>
-              <a:rPr sz="1300" b="0" i="0">
-                <a:solidFill>
-                  <a:srgbClr val="6E7671"/>
-                </a:solidFill>
-                <a:latin typeface="Calibri"/>
-              </a:rPr>
-              <a:t>The web chat and the CLI are both thin adapters over one run_turn(). A voice channel would be a sibling of those files, not a rewrite of anything underneath.</a:t>
+              <a:t>Both matter. Only one of them can be left to a language model.</a:t>
             </a:r>
           </a:p>
         </p:txBody>
@@ -5216,8 +4477,8 @@
         </p:nvSpPr>
         <p:spPr>
           <a:xfrm>
-            <a:off x="777240" y="658368"/>
-            <a:ext cx="9601200" cy="566928"/>
+            <a:off x="868680" y="868680"/>
+            <a:ext cx="10241280" cy="914400"/>
           </a:xfrm>
           <a:prstGeom prst="rect">
             <a:avLst/>
@@ -5232,17 +4493,17 @@
           <a:p>
             <a:pPr algn="l">
               <a:lnSpc>
-                <a:spcPct val="118000"/>
+                <a:spcPct val="110000"/>
               </a:lnSpc>
             </a:pPr>
             <a:r>
-              <a:rPr sz="3500" b="1" i="0">
+              <a:rPr sz="4000" b="1" i="0">
                 <a:solidFill>
                   <a:srgbClr val="14201C"/>
                 </a:solidFill>
                 <a:latin typeface="Cambria"/>
               </a:rPr>
-              <a:t>Three decisions worth defending</a:t>
+              <a:t>Every answer takes the same three steps.</a:t>
             </a:r>
           </a:p>
         </p:txBody>
@@ -5255,8 +4516,8 @@
         </p:nvSpPr>
         <p:spPr>
           <a:xfrm>
-            <a:off x="777240" y="1316736"/>
-            <a:ext cx="10332720" cy="365760"/>
+            <a:off x="868680" y="1965960"/>
+            <a:ext cx="10424160" cy="411480"/>
           </a:xfrm>
           <a:prstGeom prst="rect">
             <a:avLst/>
@@ -5271,17 +4532,17 @@
           <a:p>
             <a:pPr algn="l">
               <a:lnSpc>
-                <a:spcPct val="118000"/>
+                <a:spcPct val="120000"/>
               </a:lnSpc>
             </a:pPr>
             <a:r>
-              <a:rPr sz="1600" b="0" i="0">
+              <a:rPr sz="1700" b="0" i="0">
                 <a:solidFill>
                   <a:srgbClr val="6E7671"/>
                 </a:solidFill>
                 <a:latin typeface="Calibri"/>
               </a:rPr>
-              <a:t>Each one moves authority out of the model and into code.</a:t>
+              <a:t>The middle one is the whole argument.</a:t>
             </a:r>
           </a:p>
         </p:txBody>
@@ -5294,12 +4555,12 @@
         </p:nvSpPr>
         <p:spPr>
           <a:xfrm>
-            <a:off x="777240" y="1993392"/>
-            <a:ext cx="3301898" cy="4389120"/>
+            <a:off x="868680" y="2788920"/>
+            <a:ext cx="3210458" cy="2788920"/>
           </a:xfrm>
           <a:prstGeom prst="roundRect">
             <a:avLst>
-              <a:gd name="adj" fmla="val 2492"/>
+              <a:gd name="adj" fmla="val 3278"/>
             </a:avLst>
           </a:prstGeom>
           <a:solidFill>
@@ -5340,8 +4601,8 @@
         </p:nvSpPr>
         <p:spPr>
           <a:xfrm>
-            <a:off x="1051560" y="2194560"/>
-            <a:ext cx="914400" cy="384048"/>
+            <a:off x="1179576" y="3063239"/>
+            <a:ext cx="1097280" cy="566928"/>
           </a:xfrm>
           <a:prstGeom prst="rect">
             <a:avLst/>
@@ -5356,17 +4617,17 @@
           <a:p>
             <a:pPr algn="l">
               <a:lnSpc>
-                <a:spcPct val="118000"/>
+                <a:spcPct val="120000"/>
               </a:lnSpc>
             </a:pPr>
             <a:r>
-              <a:rPr sz="2500" b="1" i="0">
+              <a:rPr sz="3400" b="1" i="0">
                 <a:solidFill>
-                  <a:srgbClr val="8FB3A4"/>
+                  <a:srgbClr val="1F5F4F"/>
                 </a:solidFill>
                 <a:latin typeface="Cambria"/>
               </a:rPr>
-              <a:t>01</a:t>
+              <a:t>1</a:t>
             </a:r>
           </a:p>
         </p:txBody>
@@ -5379,8 +4640,8 @@
         </p:nvSpPr>
         <p:spPr>
           <a:xfrm>
-            <a:off x="1051560" y="2615184"/>
-            <a:ext cx="2753258" cy="713232"/>
+            <a:off x="1179576" y="3721608"/>
+            <a:ext cx="2588666" cy="566928"/>
           </a:xfrm>
           <a:prstGeom prst="rect">
             <a:avLst/>
@@ -5395,33 +4656,17 @@
           <a:p>
             <a:pPr algn="l">
               <a:lnSpc>
-                <a:spcPct val="114000"/>
+                <a:spcPct val="115000"/>
               </a:lnSpc>
             </a:pPr>
             <a:r>
-              <a:rPr sz="1900" b="1" i="0">
+              <a:rPr sz="2000" b="1" i="0">
                 <a:solidFill>
                   <a:srgbClr val="14201C"/>
                 </a:solidFill>
                 <a:latin typeface="Cambria"/>
               </a:rPr>
-              <a:t>Eligibility is code,</a:t>
-            </a:r>
-          </a:p>
-          <a:p>
-            <a:pPr algn="l">
-              <a:lnSpc>
-                <a:spcPct val="114000"/>
-              </a:lnSpc>
-            </a:pPr>
-            <a:r>
-              <a:rPr sz="1900" b="1" i="0">
-                <a:solidFill>
-                  <a:srgbClr val="14201C"/>
-                </a:solidFill>
-                <a:latin typeface="Cambria"/>
-              </a:rPr>
-              <a:t>not a prompt</a:t>
+              <a:t>Claude picks a tool</a:t>
             </a:r>
           </a:p>
         </p:txBody>
@@ -5434,8 +4679,8 @@
         </p:nvSpPr>
         <p:spPr>
           <a:xfrm>
-            <a:off x="1051560" y="3456432"/>
-            <a:ext cx="2753258" cy="713232"/>
+            <a:off x="1179576" y="4434840"/>
+            <a:ext cx="2588666" cy="960120"/>
           </a:xfrm>
           <a:prstGeom prst="rect">
             <a:avLst/>
@@ -5450,200 +4695,42 @@
           <a:p>
             <a:pPr algn="l">
               <a:lnSpc>
-                <a:spcPct val="126000"/>
+                <a:spcPct val="130000"/>
               </a:lnSpc>
             </a:pPr>
             <a:r>
-              <a:rPr sz="1300" b="0" i="0">
-                <a:solidFill>
-                  <a:srgbClr val="14201C"/>
-                </a:solidFill>
-                <a:latin typeface="Calibri"/>
-              </a:rPr>
-              <a:t>Refund rules live in policy.py and run as plain Python.</a:t>
-            </a:r>
-          </a:p>
-        </p:txBody>
-      </p:sp>
-      <p:sp>
-        <p:nvSpPr>
-          <p:cNvPr id="8" name="TextBox 7"/>
-          <p:cNvSpPr txBox="1"/>
-          <p:nvPr/>
-        </p:nvSpPr>
-        <p:spPr>
-          <a:xfrm>
-            <a:off x="1051560" y="4334256"/>
-            <a:ext cx="2753258" cy="219456"/>
-          </a:xfrm>
-          <a:prstGeom prst="rect">
-            <a:avLst/>
-          </a:prstGeom>
-          <a:noFill/>
-        </p:spPr>
-        <p:txBody>
-          <a:bodyPr wrap="square" lIns="0" rIns="0" tIns="0" bIns="0" anchor="t">
-            <a:spAutoFit/>
-          </a:bodyPr>
-          <a:lstStyle/>
-          <a:p>
-            <a:pPr algn="l">
-              <a:lnSpc>
-                <a:spcPct val="118000"/>
-              </a:lnSpc>
-            </a:pPr>
-            <a:r>
-              <a:rPr sz="950" b="1" i="0">
-                <a:solidFill>
-                  <a:srgbClr val="A4552B"/>
-                </a:solidFill>
-                <a:latin typeface="Calibri"/>
-              </a:rPr>
-              <a:t>TRADED AWAY</a:t>
-            </a:r>
-          </a:p>
-        </p:txBody>
-      </p:sp>
-      <p:sp>
-        <p:nvSpPr>
-          <p:cNvPr id="9" name="TextBox 8"/>
-          <p:cNvSpPr txBox="1"/>
-          <p:nvPr/>
-        </p:nvSpPr>
-        <p:spPr>
-          <a:xfrm>
-            <a:off x="1051560" y="4590288"/>
-            <a:ext cx="2753258" cy="438912"/>
-          </a:xfrm>
-          <a:prstGeom prst="rect">
-            <a:avLst/>
-          </a:prstGeom>
-          <a:noFill/>
-        </p:spPr>
-        <p:txBody>
-          <a:bodyPr wrap="square" lIns="0" rIns="0" tIns="0" bIns="0" anchor="t">
-            <a:spAutoFit/>
-          </a:bodyPr>
-          <a:lstStyle/>
-          <a:p>
-            <a:pPr algn="l">
-              <a:lnSpc>
-                <a:spcPct val="124000"/>
-              </a:lnSpc>
-            </a:pPr>
-            <a:r>
-              <a:rPr sz="1200" b="0" i="0">
+              <a:rPr sz="1350" b="0" i="0">
                 <a:solidFill>
                   <a:srgbClr val="6E7671"/>
                 </a:solidFill>
                 <a:latin typeface="Calibri"/>
               </a:rPr>
-              <a:t>Every policy change is a deploy, not a prompt edit.</a:t>
-            </a:r>
-          </a:p>
-        </p:txBody>
-      </p:sp>
-      <p:sp>
-        <p:nvSpPr>
-          <p:cNvPr id="10" name="TextBox 9"/>
-          <p:cNvSpPr txBox="1"/>
-          <p:nvPr/>
-        </p:nvSpPr>
-        <p:spPr>
-          <a:xfrm>
-            <a:off x="1051560" y="5230368"/>
-            <a:ext cx="2753258" cy="219456"/>
-          </a:xfrm>
-          <a:prstGeom prst="rect">
-            <a:avLst/>
-          </a:prstGeom>
-          <a:noFill/>
-        </p:spPr>
-        <p:txBody>
-          <a:bodyPr wrap="square" lIns="0" rIns="0" tIns="0" bIns="0" anchor="t">
-            <a:spAutoFit/>
-          </a:bodyPr>
-          <a:lstStyle/>
-          <a:p>
-            <a:pPr algn="l">
-              <a:lnSpc>
-                <a:spcPct val="118000"/>
-              </a:lnSpc>
-            </a:pPr>
-            <a:r>
-              <a:rPr sz="950" b="1" i="0">
-                <a:solidFill>
-                  <a:srgbClr val="1F5F4F"/>
-                </a:solidFill>
-                <a:latin typeface="Calibri"/>
-              </a:rPr>
-              <a:t>WORTH IT BECAUSE</a:t>
-            </a:r>
-          </a:p>
-        </p:txBody>
-      </p:sp>
-      <p:sp>
-        <p:nvSpPr>
-          <p:cNvPr id="11" name="TextBox 10"/>
-          <p:cNvSpPr txBox="1"/>
-          <p:nvPr/>
-        </p:nvSpPr>
-        <p:spPr>
-          <a:xfrm>
-            <a:off x="1051560" y="5486400"/>
-            <a:ext cx="2753258" cy="868680"/>
-          </a:xfrm>
-          <a:prstGeom prst="rect">
-            <a:avLst/>
-          </a:prstGeom>
-          <a:noFill/>
-        </p:spPr>
-        <p:txBody>
-          <a:bodyPr wrap="square" lIns="0" rIns="0" tIns="0" bIns="0" anchor="t">
-            <a:spAutoFit/>
-          </a:bodyPr>
-          <a:lstStyle/>
-          <a:p>
-            <a:pPr algn="l">
-              <a:lnSpc>
-                <a:spcPct val="124000"/>
-              </a:lnSpc>
-            </a:pPr>
-            <a:r>
-              <a:rPr sz="1200" b="0" i="0">
-                <a:solidFill>
-                  <a:srgbClr val="6E7671"/>
-                </a:solidFill>
-                <a:latin typeface="Calibri"/>
-              </a:rPr>
-              <a:t>It becomes auditable and unit-testable. There is no prompt to jailbreak, and no temperature at which 45 becomes less than 30.</a:t>
-            </a:r>
-          </a:p>
-        </p:txBody>
-      </p:sp>
-      <p:sp>
-        <p:nvSpPr>
-          <p:cNvPr id="12" name="Rounded Rectangle 11"/>
+              <a:t>It reads the message and chooses: look up this order, check this refund, search the help pages.</a:t>
+            </a:r>
+          </a:p>
+        </p:txBody>
+      </p:sp>
+      <p:sp>
+        <p:nvSpPr>
+          <p:cNvPr id="8" name="Rounded Rectangle 7"/>
           <p:cNvSpPr/>
           <p:nvPr/>
         </p:nvSpPr>
         <p:spPr>
           <a:xfrm>
-            <a:off x="4444898" y="1993392"/>
-            <a:ext cx="3301898" cy="4389120"/>
+            <a:off x="4490618" y="2788920"/>
+            <a:ext cx="3210458" cy="2788920"/>
           </a:xfrm>
           <a:prstGeom prst="roundRect">
             <a:avLst>
-              <a:gd name="adj" fmla="val 2492"/>
+              <a:gd name="adj" fmla="val 3278"/>
             </a:avLst>
           </a:prstGeom>
           <a:solidFill>
-            <a:srgbClr val="FFFFFF"/>
+            <a:srgbClr val="E8F0ED"/>
           </a:solidFill>
-          <a:ln w="12700">
-            <a:solidFill>
-              <a:srgbClr val="DEDDD8"/>
-            </a:solidFill>
+          <a:ln>
+            <a:noFill/>
           </a:ln>
           <a:effectLst/>
         </p:spPr>
@@ -5669,14 +4756,14 @@
       </p:sp>
       <p:sp>
         <p:nvSpPr>
-          <p:cNvPr id="13" name="TextBox 12"/>
+          <p:cNvPr id="9" name="TextBox 8"/>
           <p:cNvSpPr txBox="1"/>
           <p:nvPr/>
         </p:nvSpPr>
         <p:spPr>
           <a:xfrm>
-            <a:off x="4719218" y="2194560"/>
-            <a:ext cx="914400" cy="384048"/>
+            <a:off x="4801514" y="3063239"/>
+            <a:ext cx="1097280" cy="566928"/>
           </a:xfrm>
           <a:prstGeom prst="rect">
             <a:avLst/>
@@ -5691,31 +4778,31 @@
           <a:p>
             <a:pPr algn="l">
               <a:lnSpc>
-                <a:spcPct val="118000"/>
+                <a:spcPct val="120000"/>
               </a:lnSpc>
             </a:pPr>
             <a:r>
-              <a:rPr sz="2500" b="1" i="0">
+              <a:rPr sz="3400" b="1" i="0">
                 <a:solidFill>
-                  <a:srgbClr val="8FB3A4"/>
+                  <a:srgbClr val="A4552B"/>
                 </a:solidFill>
                 <a:latin typeface="Cambria"/>
               </a:rPr>
-              <a:t>02</a:t>
-            </a:r>
-          </a:p>
-        </p:txBody>
-      </p:sp>
-      <p:sp>
-        <p:nvSpPr>
-          <p:cNvPr id="14" name="TextBox 13"/>
+              <a:t>2</a:t>
+            </a:r>
+          </a:p>
+        </p:txBody>
+      </p:sp>
+      <p:sp>
+        <p:nvSpPr>
+          <p:cNvPr id="10" name="TextBox 9"/>
           <p:cNvSpPr txBox="1"/>
           <p:nvPr/>
         </p:nvSpPr>
         <p:spPr>
           <a:xfrm>
-            <a:off x="4719218" y="2615184"/>
-            <a:ext cx="2753258" cy="713232"/>
+            <a:off x="4801514" y="3721608"/>
+            <a:ext cx="2588666" cy="566928"/>
           </a:xfrm>
           <a:prstGeom prst="rect">
             <a:avLst/>
@@ -5730,47 +4817,31 @@
           <a:p>
             <a:pPr algn="l">
               <a:lnSpc>
-                <a:spcPct val="114000"/>
+                <a:spcPct val="115000"/>
               </a:lnSpc>
             </a:pPr>
             <a:r>
-              <a:rPr sz="1900" b="1" i="0">
+              <a:rPr sz="2000" b="1" i="0">
                 <a:solidFill>
                   <a:srgbClr val="14201C"/>
                 </a:solidFill>
                 <a:latin typeface="Cambria"/>
               </a:rPr>
-              <a:t>The write tool has</a:t>
-            </a:r>
-          </a:p>
-          <a:p>
-            <a:pPr algn="l">
-              <a:lnSpc>
-                <a:spcPct val="114000"/>
-              </a:lnSpc>
-            </a:pPr>
-            <a:r>
-              <a:rPr sz="1900" b="1" i="0">
-                <a:solidFill>
-                  <a:srgbClr val="14201C"/>
-                </a:solidFill>
-                <a:latin typeface="Cambria"/>
-              </a:rPr>
-              <a:t>preconditions</a:t>
-            </a:r>
-          </a:p>
-        </p:txBody>
-      </p:sp>
-      <p:sp>
-        <p:nvSpPr>
-          <p:cNvPr id="15" name="TextBox 14"/>
+              <a:t>Python decides</a:t>
+            </a:r>
+          </a:p>
+        </p:txBody>
+      </p:sp>
+      <p:sp>
+        <p:nvSpPr>
+          <p:cNvPr id="11" name="TextBox 10"/>
           <p:cNvSpPr txBox="1"/>
           <p:nvPr/>
         </p:nvSpPr>
         <p:spPr>
           <a:xfrm>
-            <a:off x="4719218" y="3456432"/>
-            <a:ext cx="2753258" cy="713232"/>
+            <a:off x="4801514" y="4434840"/>
+            <a:ext cx="2588666" cy="960120"/>
           </a:xfrm>
           <a:prstGeom prst="rect">
             <a:avLst/>
@@ -5785,191 +4856,35 @@
           <a:p>
             <a:pPr algn="l">
               <a:lnSpc>
-                <a:spcPct val="126000"/>
+                <a:spcPct val="130000"/>
               </a:lnSpc>
             </a:pPr>
             <a:r>
-              <a:rPr sz="1300" b="0" i="0">
-                <a:solidFill>
-                  <a:srgbClr val="14201C"/>
-                </a:solidFill>
-                <a:latin typeface="Calibri"/>
-              </a:rPr>
-              <a:t>issue_refund refuses unless identity was verified, eligibility passed, and the customer said yes.</a:t>
-            </a:r>
-          </a:p>
-        </p:txBody>
-      </p:sp>
-      <p:sp>
-        <p:nvSpPr>
-          <p:cNvPr id="16" name="TextBox 15"/>
-          <p:cNvSpPr txBox="1"/>
-          <p:nvPr/>
-        </p:nvSpPr>
-        <p:spPr>
-          <a:xfrm>
-            <a:off x="4719218" y="4334256"/>
-            <a:ext cx="2753258" cy="219456"/>
-          </a:xfrm>
-          <a:prstGeom prst="rect">
-            <a:avLst/>
-          </a:prstGeom>
-          <a:noFill/>
-        </p:spPr>
-        <p:txBody>
-          <a:bodyPr wrap="square" lIns="0" rIns="0" tIns="0" bIns="0" anchor="t">
-            <a:spAutoFit/>
-          </a:bodyPr>
-          <a:lstStyle/>
-          <a:p>
-            <a:pPr algn="l">
-              <a:lnSpc>
-                <a:spcPct val="118000"/>
-              </a:lnSpc>
-            </a:pPr>
-            <a:r>
-              <a:rPr sz="950" b="1" i="0">
-                <a:solidFill>
-                  <a:srgbClr val="A4552B"/>
-                </a:solidFill>
-                <a:latin typeface="Calibri"/>
-              </a:rPr>
-              <a:t>TRADED AWAY</a:t>
-            </a:r>
-          </a:p>
-        </p:txBody>
-      </p:sp>
-      <p:sp>
-        <p:nvSpPr>
-          <p:cNvPr id="17" name="TextBox 16"/>
-          <p:cNvSpPr txBox="1"/>
-          <p:nvPr/>
-        </p:nvSpPr>
-        <p:spPr>
-          <a:xfrm>
-            <a:off x="4719218" y="4590288"/>
-            <a:ext cx="2753258" cy="438912"/>
-          </a:xfrm>
-          <a:prstGeom prst="rect">
-            <a:avLst/>
-          </a:prstGeom>
-          <a:noFill/>
-        </p:spPr>
-        <p:txBody>
-          <a:bodyPr wrap="square" lIns="0" rIns="0" tIns="0" bIns="0" anchor="t">
-            <a:spAutoFit/>
-          </a:bodyPr>
-          <a:lstStyle/>
-          <a:p>
-            <a:pPr algn="l">
-              <a:lnSpc>
-                <a:spcPct val="124000"/>
-              </a:lnSpc>
-            </a:pPr>
-            <a:r>
-              <a:rPr sz="1200" b="0" i="0">
+              <a:rPr sz="1350" b="0" i="0">
                 <a:solidFill>
                   <a:srgbClr val="6E7671"/>
                 </a:solidFill>
                 <a:latin typeface="Calibri"/>
               </a:rPr>
-              <a:t>More code than a line of prompt instruction.</a:t>
-            </a:r>
-          </a:p>
-        </p:txBody>
-      </p:sp>
-      <p:sp>
-        <p:nvSpPr>
-          <p:cNvPr id="18" name="TextBox 17"/>
-          <p:cNvSpPr txBox="1"/>
-          <p:nvPr/>
-        </p:nvSpPr>
-        <p:spPr>
-          <a:xfrm>
-            <a:off x="4719218" y="5230368"/>
-            <a:ext cx="2753258" cy="219456"/>
-          </a:xfrm>
-          <a:prstGeom prst="rect">
-            <a:avLst/>
-          </a:prstGeom>
-          <a:noFill/>
-        </p:spPr>
-        <p:txBody>
-          <a:bodyPr wrap="square" lIns="0" rIns="0" tIns="0" bIns="0" anchor="t">
-            <a:spAutoFit/>
-          </a:bodyPr>
-          <a:lstStyle/>
-          <a:p>
-            <a:pPr algn="l">
-              <a:lnSpc>
-                <a:spcPct val="118000"/>
-              </a:lnSpc>
-            </a:pPr>
-            <a:r>
-              <a:rPr sz="950" b="1" i="0">
-                <a:solidFill>
-                  <a:srgbClr val="1F5F4F"/>
-                </a:solidFill>
-                <a:latin typeface="Calibri"/>
-              </a:rPr>
-              <a:t>WORTH IT BECAUSE</a:t>
-            </a:r>
-          </a:p>
-        </p:txBody>
-      </p:sp>
-      <p:sp>
-        <p:nvSpPr>
-          <p:cNvPr id="19" name="TextBox 18"/>
-          <p:cNvSpPr txBox="1"/>
-          <p:nvPr/>
-        </p:nvSpPr>
-        <p:spPr>
-          <a:xfrm>
-            <a:off x="4719218" y="5486400"/>
-            <a:ext cx="2753258" cy="868680"/>
-          </a:xfrm>
-          <a:prstGeom prst="rect">
-            <a:avLst/>
-          </a:prstGeom>
-          <a:noFill/>
-        </p:spPr>
-        <p:txBody>
-          <a:bodyPr wrap="square" lIns="0" rIns="0" tIns="0" bIns="0" anchor="t">
-            <a:spAutoFit/>
-          </a:bodyPr>
-          <a:lstStyle/>
-          <a:p>
-            <a:pPr algn="l">
-              <a:lnSpc>
-                <a:spcPct val="124000"/>
-              </a:lnSpc>
-            </a:pPr>
-            <a:r>
-              <a:rPr sz="1200" b="0" i="0">
-                <a:solidFill>
-                  <a:srgbClr val="6E7671"/>
-                </a:solidFill>
-                <a:latin typeface="Calibri"/>
-              </a:rPr>
-              <a:t>"Always confirm first" is a suggestion. This is a precondition. The model is now allowed to be wrong without the customer paying for it.</a:t>
-            </a:r>
-          </a:p>
-        </p:txBody>
-      </p:sp>
-      <p:sp>
-        <p:nvSpPr>
-          <p:cNvPr id="20" name="Rounded Rectangle 19"/>
+              <a:t>45 days since delivery. The window is 30. The answer is no — computed by code, not judged by the model.</a:t>
+            </a:r>
+          </a:p>
+        </p:txBody>
+      </p:sp>
+      <p:sp>
+        <p:nvSpPr>
+          <p:cNvPr id="12" name="Rounded Rectangle 11"/>
           <p:cNvSpPr/>
           <p:nvPr/>
         </p:nvSpPr>
         <p:spPr>
           <a:xfrm>
-            <a:off x="8112556" y="1993392"/>
-            <a:ext cx="3301898" cy="4389120"/>
+            <a:off x="8112556" y="2788920"/>
+            <a:ext cx="3210458" cy="2788920"/>
           </a:xfrm>
           <a:prstGeom prst="roundRect">
             <a:avLst>
-              <a:gd name="adj" fmla="val 2492"/>
+              <a:gd name="adj" fmla="val 3278"/>
             </a:avLst>
           </a:prstGeom>
           <a:solidFill>
@@ -6004,14 +4919,14 @@
       </p:sp>
       <p:sp>
         <p:nvSpPr>
-          <p:cNvPr id="21" name="TextBox 20"/>
+          <p:cNvPr id="13" name="TextBox 12"/>
           <p:cNvSpPr txBox="1"/>
           <p:nvPr/>
         </p:nvSpPr>
         <p:spPr>
           <a:xfrm>
-            <a:off x="8386876" y="2194560"/>
-            <a:ext cx="914400" cy="384048"/>
+            <a:off x="8423452" y="3063239"/>
+            <a:ext cx="1097280" cy="566928"/>
           </a:xfrm>
           <a:prstGeom prst="rect">
             <a:avLst/>
@@ -6026,31 +4941,31 @@
           <a:p>
             <a:pPr algn="l">
               <a:lnSpc>
-                <a:spcPct val="118000"/>
+                <a:spcPct val="120000"/>
               </a:lnSpc>
             </a:pPr>
             <a:r>
-              <a:rPr sz="2500" b="1" i="0">
+              <a:rPr sz="3400" b="1" i="0">
                 <a:solidFill>
-                  <a:srgbClr val="8FB3A4"/>
+                  <a:srgbClr val="1F5F4F"/>
                 </a:solidFill>
                 <a:latin typeface="Cambria"/>
               </a:rPr>
-              <a:t>03</a:t>
-            </a:r>
-          </a:p>
-        </p:txBody>
-      </p:sp>
-      <p:sp>
-        <p:nvSpPr>
-          <p:cNvPr id="22" name="TextBox 21"/>
+              <a:t>3</a:t>
+            </a:r>
+          </a:p>
+        </p:txBody>
+      </p:sp>
+      <p:sp>
+        <p:nvSpPr>
+          <p:cNvPr id="14" name="TextBox 13"/>
           <p:cNvSpPr txBox="1"/>
           <p:nvPr/>
         </p:nvSpPr>
         <p:spPr>
           <a:xfrm>
-            <a:off x="8386876" y="2615184"/>
-            <a:ext cx="2753258" cy="713232"/>
+            <a:off x="8423452" y="3721608"/>
+            <a:ext cx="2588666" cy="566928"/>
           </a:xfrm>
           <a:prstGeom prst="rect">
             <a:avLst/>
@@ -6065,47 +4980,31 @@
           <a:p>
             <a:pPr algn="l">
               <a:lnSpc>
-                <a:spcPct val="114000"/>
+                <a:spcPct val="115000"/>
               </a:lnSpc>
             </a:pPr>
             <a:r>
-              <a:rPr sz="1900" b="1" i="0">
+              <a:rPr sz="2000" b="1" i="0">
                 <a:solidFill>
                   <a:srgbClr val="14201C"/>
                 </a:solidFill>
                 <a:latin typeface="Cambria"/>
               </a:rPr>
-              <a:t>Required arguments</a:t>
-            </a:r>
-          </a:p>
-          <a:p>
-            <a:pPr algn="l">
-              <a:lnSpc>
-                <a:spcPct val="114000"/>
-              </a:lnSpc>
-            </a:pPr>
-            <a:r>
-              <a:rPr sz="1900" b="1" i="0">
-                <a:solidFill>
-                  <a:srgbClr val="14201C"/>
-                </a:solidFill>
-                <a:latin typeface="Cambria"/>
-              </a:rPr>
-              <a:t>generate the dialogue</a:t>
-            </a:r>
-          </a:p>
-        </p:txBody>
-      </p:sp>
-      <p:sp>
-        <p:nvSpPr>
-          <p:cNvPr id="23" name="TextBox 22"/>
+              <a:t>Claude replies</a:t>
+            </a:r>
+          </a:p>
+        </p:txBody>
+      </p:sp>
+      <p:sp>
+        <p:nvSpPr>
+          <p:cNvPr id="15" name="TextBox 14"/>
           <p:cNvSpPr txBox="1"/>
           <p:nvPr/>
         </p:nvSpPr>
         <p:spPr>
           <a:xfrm>
-            <a:off x="8386876" y="3456432"/>
-            <a:ext cx="2753258" cy="713232"/>
+            <a:off x="8423452" y="4434840"/>
+            <a:ext cx="2588666" cy="960120"/>
           </a:xfrm>
           <a:prstGeom prst="rect">
             <a:avLst/>
@@ -6120,173 +5019,17 @@
           <a:p>
             <a:pPr algn="l">
               <a:lnSpc>
-                <a:spcPct val="126000"/>
+                <a:spcPct val="130000"/>
               </a:lnSpc>
             </a:pPr>
             <a:r>
-              <a:rPr sz="1300" b="0" i="0">
-                <a:solidFill>
-                  <a:srgbClr val="14201C"/>
-                </a:solidFill>
-                <a:latin typeface="Calibri"/>
-              </a:rPr>
-              <a:t>lookup_order cannot be called without both an order id and an email.</a:t>
-            </a:r>
-          </a:p>
-        </p:txBody>
-      </p:sp>
-      <p:sp>
-        <p:nvSpPr>
-          <p:cNvPr id="24" name="TextBox 23"/>
-          <p:cNvSpPr txBox="1"/>
-          <p:nvPr/>
-        </p:nvSpPr>
-        <p:spPr>
-          <a:xfrm>
-            <a:off x="8386876" y="4334256"/>
-            <a:ext cx="2753258" cy="219456"/>
-          </a:xfrm>
-          <a:prstGeom prst="rect">
-            <a:avLst/>
-          </a:prstGeom>
-          <a:noFill/>
-        </p:spPr>
-        <p:txBody>
-          <a:bodyPr wrap="square" lIns="0" rIns="0" tIns="0" bIns="0" anchor="t">
-            <a:spAutoFit/>
-          </a:bodyPr>
-          <a:lstStyle/>
-          <a:p>
-            <a:pPr algn="l">
-              <a:lnSpc>
-                <a:spcPct val="118000"/>
-              </a:lnSpc>
-            </a:pPr>
-            <a:r>
-              <a:rPr sz="950" b="1" i="0">
-                <a:solidFill>
-                  <a:srgbClr val="A4552B"/>
-                </a:solidFill>
-                <a:latin typeface="Calibri"/>
-              </a:rPr>
-              <a:t>TRADED AWAY</a:t>
-            </a:r>
-          </a:p>
-        </p:txBody>
-      </p:sp>
-      <p:sp>
-        <p:nvSpPr>
-          <p:cNvPr id="25" name="TextBox 24"/>
-          <p:cNvSpPr txBox="1"/>
-          <p:nvPr/>
-        </p:nvSpPr>
-        <p:spPr>
-          <a:xfrm>
-            <a:off x="8386876" y="4590288"/>
-            <a:ext cx="2753258" cy="438912"/>
-          </a:xfrm>
-          <a:prstGeom prst="rect">
-            <a:avLst/>
-          </a:prstGeom>
-          <a:noFill/>
-        </p:spPr>
-        <p:txBody>
-          <a:bodyPr wrap="square" lIns="0" rIns="0" tIns="0" bIns="0" anchor="t">
-            <a:spAutoFit/>
-          </a:bodyPr>
-          <a:lstStyle/>
-          <a:p>
-            <a:pPr algn="l">
-              <a:lnSpc>
-                <a:spcPct val="124000"/>
-              </a:lnSpc>
-            </a:pPr>
-            <a:r>
-              <a:rPr sz="1200" b="0" i="0">
+              <a:rPr sz="1350" b="0" i="0">
                 <a:solidFill>
                   <a:srgbClr val="6E7671"/>
                 </a:solidFill>
                 <a:latin typeface="Calibri"/>
               </a:rPr>
-              <a:t>Less freedom in how the agent phrases its way there.</a:t>
-            </a:r>
-          </a:p>
-        </p:txBody>
-      </p:sp>
-      <p:sp>
-        <p:nvSpPr>
-          <p:cNvPr id="26" name="TextBox 25"/>
-          <p:cNvSpPr txBox="1"/>
-          <p:nvPr/>
-        </p:nvSpPr>
-        <p:spPr>
-          <a:xfrm>
-            <a:off x="8386876" y="5230368"/>
-            <a:ext cx="2753258" cy="219456"/>
-          </a:xfrm>
-          <a:prstGeom prst="rect">
-            <a:avLst/>
-          </a:prstGeom>
-          <a:noFill/>
-        </p:spPr>
-        <p:txBody>
-          <a:bodyPr wrap="square" lIns="0" rIns="0" tIns="0" bIns="0" anchor="t">
-            <a:spAutoFit/>
-          </a:bodyPr>
-          <a:lstStyle/>
-          <a:p>
-            <a:pPr algn="l">
-              <a:lnSpc>
-                <a:spcPct val="118000"/>
-              </a:lnSpc>
-            </a:pPr>
-            <a:r>
-              <a:rPr sz="950" b="1" i="0">
-                <a:solidFill>
-                  <a:srgbClr val="1F5F4F"/>
-                </a:solidFill>
-                <a:latin typeface="Calibri"/>
-              </a:rPr>
-              <a:t>WORTH IT BECAUSE</a:t>
-            </a:r>
-          </a:p>
-        </p:txBody>
-      </p:sp>
-      <p:sp>
-        <p:nvSpPr>
-          <p:cNvPr id="27" name="TextBox 26"/>
-          <p:cNvSpPr txBox="1"/>
-          <p:nvPr/>
-        </p:nvSpPr>
-        <p:spPr>
-          <a:xfrm>
-            <a:off x="8386876" y="5486400"/>
-            <a:ext cx="2753258" cy="868680"/>
-          </a:xfrm>
-          <a:prstGeom prst="rect">
-            <a:avLst/>
-          </a:prstGeom>
-          <a:noFill/>
-        </p:spPr>
-        <p:txBody>
-          <a:bodyPr wrap="square" lIns="0" rIns="0" tIns="0" bIns="0" anchor="t">
-            <a:spAutoFit/>
-          </a:bodyPr>
-          <a:lstStyle/>
-          <a:p>
-            <a:pPr algn="l">
-              <a:lnSpc>
-                <a:spcPct val="124000"/>
-              </a:lnSpc>
-            </a:pPr>
-            <a:r>
-              <a:rPr sz="1200" b="0" i="0">
-                <a:solidFill>
-                  <a:srgbClr val="6E7671"/>
-                </a:solidFill>
-                <a:latin typeface="Calibri"/>
-              </a:rPr>
-              <a:t>Nobody wrote a script for collecting them. The schema makes a half-informed call impossible, so the agent asks. Flow control by type signature.</a:t>
+              <a:t>It explains the outcome kindly. It is not allowed to overturn step 2, however the customer asks.</a:t>
             </a:r>
           </a:p>
         </p:txBody>
@@ -6325,8 +5068,8 @@
         </p:nvSpPr>
         <p:spPr>
           <a:xfrm>
-            <a:off x="777240" y="658368"/>
-            <a:ext cx="9601200" cy="566928"/>
+            <a:off x="868680" y="868680"/>
+            <a:ext cx="10241280" cy="914400"/>
           </a:xfrm>
           <a:prstGeom prst="rect">
             <a:avLst/>
@@ -6341,17 +5084,17 @@
           <a:p>
             <a:pPr algn="l">
               <a:lnSpc>
-                <a:spcPct val="118000"/>
+                <a:spcPct val="110000"/>
               </a:lnSpc>
             </a:pPr>
             <a:r>
-              <a:rPr sz="3500" b="1" i="0">
+              <a:rPr sz="4000" b="1" i="0">
                 <a:solidFill>
                   <a:srgbClr val="14201C"/>
                 </a:solidFill>
                 <a:latin typeface="Cambria"/>
               </a:rPr>
-              <a:t>Where the architecture shows up</a:t>
+              <a:t>45 days old. The answer is no — every time.</a:t>
             </a:r>
           </a:p>
         </p:txBody>
@@ -6364,8 +5107,8 @@
         </p:nvSpPr>
         <p:spPr>
           <a:xfrm>
-            <a:off x="777240" y="1316736"/>
-            <a:ext cx="10332720" cy="365760"/>
+            <a:off x="868680" y="1965960"/>
+            <a:ext cx="10424160" cy="411480"/>
           </a:xfrm>
           <a:prstGeom prst="rect">
             <a:avLst/>
@@ -6380,17 +5123,17 @@
           <a:p>
             <a:pPr algn="l">
               <a:lnSpc>
-                <a:spcPct val="118000"/>
+                <a:spcPct val="120000"/>
               </a:lnSpc>
             </a:pPr>
             <a:r>
-              <a:rPr sz="1600" b="0" i="0">
+              <a:rPr sz="1700" b="0" i="0">
                 <a:solidFill>
                   <a:srgbClr val="6E7671"/>
                 </a:solidFill>
                 <a:latin typeface="Calibri"/>
               </a:rPr>
-              <a:t>Three moments from the demo, and one experiment.</a:t>
+              <a:t>A real exchange from the running agent.</a:t>
             </a:r>
           </a:p>
         </p:txBody>
@@ -6403,16 +5146,16 @@
         </p:nvSpPr>
         <p:spPr>
           <a:xfrm>
-            <a:off x="777240" y="2029968"/>
-            <a:ext cx="5138928" cy="1481328"/>
+            <a:off x="5760720" y="2468880"/>
+            <a:ext cx="5577840" cy="658368"/>
           </a:xfrm>
           <a:prstGeom prst="roundRect">
             <a:avLst>
-              <a:gd name="adj" fmla="val 5555"/>
+              <a:gd name="adj" fmla="val 22222"/>
             </a:avLst>
           </a:prstGeom>
           <a:solidFill>
-            <a:srgbClr val="F5E7DE"/>
+            <a:srgbClr val="1F5F4F"/>
           </a:solidFill>
           <a:ln>
             <a:noFill/>
@@ -6447,8 +5190,8 @@
         </p:nvSpPr>
         <p:spPr>
           <a:xfrm>
-            <a:off x="1069848" y="2231136"/>
-            <a:ext cx="4553712" cy="256032"/>
+            <a:off x="6053328" y="2642616"/>
+            <a:ext cx="4992624" cy="384048"/>
           </a:xfrm>
           <a:prstGeom prst="rect">
             <a:avLst/>
@@ -6463,74 +5206,35 @@
           <a:p>
             <a:pPr algn="l">
               <a:lnSpc>
-                <a:spcPct val="118000"/>
+                <a:spcPct val="120000"/>
               </a:lnSpc>
             </a:pPr>
             <a:r>
-              <a:rPr sz="1100" b="1" i="0">
+              <a:rPr sz="1350" b="0" i="0">
                 <a:solidFill>
-                  <a:srgbClr val="A4552B"/>
+                  <a:srgbClr val="FFFFFF"/>
                 </a:solidFill>
                 <a:latin typeface="Calibri"/>
               </a:rPr>
-              <a:t>IT SAYS NO, AND MEANS IT</a:t>
-            </a:r>
-          </a:p>
-        </p:txBody>
-      </p:sp>
-      <p:sp>
-        <p:nvSpPr>
-          <p:cNvPr id="6" name="TextBox 5"/>
-          <p:cNvSpPr txBox="1"/>
-          <p:nvPr/>
-        </p:nvSpPr>
-        <p:spPr>
-          <a:xfrm>
-            <a:off x="1069848" y="2542032"/>
-            <a:ext cx="4553712" cy="841248"/>
-          </a:xfrm>
-          <a:prstGeom prst="rect">
-            <a:avLst/>
-          </a:prstGeom>
-          <a:noFill/>
-        </p:spPr>
-        <p:txBody>
-          <a:bodyPr wrap="square" lIns="0" rIns="0" tIns="0" bIns="0" anchor="t">
-            <a:spAutoFit/>
-          </a:bodyPr>
-          <a:lstStyle/>
-          <a:p>
-            <a:pPr algn="l">
-              <a:lnSpc>
-                <a:spcPct val="128000"/>
-              </a:lnSpc>
-            </a:pPr>
-            <a:r>
-              <a:rPr sz="1350" b="0" i="0">
-                <a:solidFill>
-                  <a:srgbClr val="14201C"/>
-                </a:solidFill>
-                <a:latin typeface="Calibri"/>
-              </a:rPr>
-              <a:t>A refund request on an order delivered 45 days ago. The agent checks, refuses, explains why, and offers a human. It cannot be argued out of the number 30.</a:t>
-            </a:r>
-          </a:p>
-        </p:txBody>
-      </p:sp>
-      <p:sp>
-        <p:nvSpPr>
-          <p:cNvPr id="7" name="Rounded Rectangle 6"/>
+              <a:t>I want a refund for BK-1002, ada.lovelace@example.com</a:t>
+            </a:r>
+          </a:p>
+        </p:txBody>
+      </p:sp>
+      <p:sp>
+        <p:nvSpPr>
+          <p:cNvPr id="6" name="Rounded Rectangle 5"/>
           <p:cNvSpPr/>
           <p:nvPr/>
         </p:nvSpPr>
         <p:spPr>
           <a:xfrm>
-            <a:off x="6272783" y="2029968"/>
-            <a:ext cx="5138928" cy="1481328"/>
+            <a:off x="868680" y="3337560"/>
+            <a:ext cx="8092440" cy="1572768"/>
           </a:xfrm>
           <a:prstGeom prst="roundRect">
             <a:avLst>
-              <a:gd name="adj" fmla="val 5555"/>
+              <a:gd name="adj" fmla="val 9302"/>
             </a:avLst>
           </a:prstGeom>
           <a:solidFill>
@@ -6565,14 +5269,14 @@
       </p:sp>
       <p:sp>
         <p:nvSpPr>
-          <p:cNvPr id="8" name="TextBox 7"/>
+          <p:cNvPr id="7" name="TextBox 6"/>
           <p:cNvSpPr txBox="1"/>
           <p:nvPr/>
         </p:nvSpPr>
         <p:spPr>
           <a:xfrm>
-            <a:off x="6565392" y="2231136"/>
-            <a:ext cx="4553712" cy="256032"/>
+            <a:off x="1179576" y="3547872"/>
+            <a:ext cx="7470648" cy="1188720"/>
           </a:xfrm>
           <a:prstGeom prst="rect">
             <a:avLst/>
@@ -6587,47 +5291,11 @@
           <a:p>
             <a:pPr algn="l">
               <a:lnSpc>
-                <a:spcPct val="118000"/>
+                <a:spcPct val="134000"/>
               </a:lnSpc>
-            </a:pPr>
-            <a:r>
-              <a:rPr sz="1100" b="1" i="0">
-                <a:solidFill>
-                  <a:srgbClr val="1F5F4F"/>
-                </a:solidFill>
-                <a:latin typeface="Calibri"/>
-              </a:rPr>
-              <a:t>IT ASKS INSTEAD OF GUESSING</a:t>
-            </a:r>
-          </a:p>
-        </p:txBody>
-      </p:sp>
-      <p:sp>
-        <p:nvSpPr>
-          <p:cNvPr id="9" name="TextBox 8"/>
-          <p:cNvSpPr txBox="1"/>
-          <p:nvPr/>
-        </p:nvSpPr>
-        <p:spPr>
-          <a:xfrm>
-            <a:off x="6565392" y="2542032"/>
-            <a:ext cx="4553712" cy="841248"/>
-          </a:xfrm>
-          <a:prstGeom prst="rect">
-            <a:avLst/>
-          </a:prstGeom>
-          <a:noFill/>
-        </p:spPr>
-        <p:txBody>
-          <a:bodyPr wrap="square" lIns="0" rIns="0" tIns="0" bIns="0" anchor="t">
-            <a:spAutoFit/>
-          </a:bodyPr>
-          <a:lstStyle/>
-          <a:p>
-            <a:pPr algn="l">
-              <a:lnSpc>
-                <a:spcPct val="128000"/>
-              </a:lnSpc>
+              <a:spcAft>
+                <a:spcPts val="600"/>
+              </a:spcAft>
             </a:pPr>
             <a:r>
               <a:rPr sz="1350" b="0" i="0">
@@ -6636,29 +5304,48 @@
                 </a:solidFill>
                 <a:latin typeface="Calibri"/>
               </a:rPr>
-              <a:t>"I want to return my book" on an order containing two books. It names both and asks which — rather than picking one and being wrong half the time.</a:t>
-            </a:r>
-          </a:p>
-        </p:txBody>
-      </p:sp>
-      <p:sp>
-        <p:nvSpPr>
-          <p:cNvPr id="10" name="Rounded Rectangle 9"/>
+              <a:t>I checked, and unfortunately BK-1002 isn't eligible for a refund — your copy of Piranesi was delivered on 23 July, 45 days ago, which falls outside the 30-day return window.</a:t>
+            </a:r>
+          </a:p>
+          <a:p>
+            <a:pPr algn="l">
+              <a:lnSpc>
+                <a:spcPct val="134000"/>
+              </a:lnSpc>
+              <a:spcAft>
+                <a:spcPts val="600"/>
+              </a:spcAft>
+            </a:pPr>
+            <a:r>
+              <a:rPr sz="1350" b="0" i="0">
+                <a:solidFill>
+                  <a:srgbClr val="14201C"/>
+                </a:solidFill>
+                <a:latin typeface="Calibri"/>
+              </a:rPr>
+              <a:t>I'm sorry to give you that answer. If you'd like, I can pass this to a human colleague to take another look.</a:t>
+            </a:r>
+          </a:p>
+        </p:txBody>
+      </p:sp>
+      <p:sp>
+        <p:nvSpPr>
+          <p:cNvPr id="8" name="Rounded Rectangle 7"/>
           <p:cNvSpPr/>
           <p:nvPr/>
         </p:nvSpPr>
         <p:spPr>
           <a:xfrm>
-            <a:off x="777240" y="3803904"/>
-            <a:ext cx="10634472" cy="1975104"/>
+            <a:off x="868680" y="5138928"/>
+            <a:ext cx="10451592" cy="1024128"/>
           </a:xfrm>
           <a:prstGeom prst="roundRect">
             <a:avLst>
-              <a:gd name="adj" fmla="val 4166"/>
+              <a:gd name="adj" fmla="val 8928"/>
             </a:avLst>
           </a:prstGeom>
           <a:solidFill>
-            <a:srgbClr val="1F5F4F"/>
+            <a:srgbClr val="14161A"/>
           </a:solidFill>
           <a:ln>
             <a:noFill/>
@@ -6687,14 +5374,14 @@
       </p:sp>
       <p:sp>
         <p:nvSpPr>
-          <p:cNvPr id="11" name="TextBox 10"/>
+          <p:cNvPr id="9" name="TextBox 8"/>
           <p:cNvSpPr txBox="1"/>
           <p:nvPr/>
         </p:nvSpPr>
         <p:spPr>
           <a:xfrm>
-            <a:off x="1088136" y="4041648"/>
-            <a:ext cx="5486400" cy="274320"/>
+            <a:off x="1197864" y="5321808"/>
+            <a:ext cx="4572000" cy="274320"/>
           </a:xfrm>
           <a:prstGeom prst="rect">
             <a:avLst/>
@@ -6709,31 +5396,31 @@
           <a:p>
             <a:pPr algn="l">
               <a:lnSpc>
-                <a:spcPct val="118000"/>
+                <a:spcPct val="120000"/>
               </a:lnSpc>
             </a:pPr>
             <a:r>
               <a:rPr sz="1100" b="1" i="0">
                 <a:solidFill>
-                  <a:srgbClr val="8FB3A4"/>
+                  <a:srgbClr val="6B7684"/>
                 </a:solidFill>
                 <a:latin typeface="Calibri"/>
               </a:rPr>
-              <a:t>THE EXPERIMENT WORTH RUNNING</a:t>
-            </a:r>
-          </a:p>
-        </p:txBody>
-      </p:sp>
-      <p:sp>
-        <p:nvSpPr>
-          <p:cNvPr id="12" name="TextBox 11"/>
+              <a:t>WHAT IT DID UNDERNEATH</a:t>
+            </a:r>
+          </a:p>
+        </p:txBody>
+      </p:sp>
+      <p:sp>
+        <p:nvSpPr>
+          <p:cNvPr id="10" name="TextBox 9"/>
           <p:cNvSpPr txBox="1"/>
           <p:nvPr/>
         </p:nvSpPr>
         <p:spPr>
           <a:xfrm>
-            <a:off x="1088136" y="4370832"/>
-            <a:ext cx="10058400" cy="1207008"/>
+            <a:off x="1197864" y="5632704"/>
+            <a:ext cx="9784080" cy="365760"/>
           </a:xfrm>
           <a:prstGeom prst="rect">
             <a:avLst/>
@@ -6748,72 +5435,35 @@
           <a:p>
             <a:pPr algn="l">
               <a:lnSpc>
-                <a:spcPct val="134000"/>
+                <a:spcPct val="120000"/>
               </a:lnSpc>
             </a:pPr>
             <a:r>
-              <a:rPr sz="1600" b="0" i="0">
+              <a:rPr sz="1300" b="0" i="0">
                 <a:solidFill>
-                  <a:srgbClr val="FFFFFF"/>
+                  <a:srgbClr val="9DB4AB"/>
                 </a:solidFill>
-                <a:latin typeface="Calibri"/>
+                <a:latin typeface="Courier New"/>
               </a:rPr>
-              <a:t>Delete the API key and the agent falls back to a scripted, rule-based planner. It is far worse at understanding English — and every single guardrail still holds. Identity is still checked, the 30-day rule still bites, refunds still need confirmation.</a:t>
-            </a:r>
-          </a:p>
-          <a:p>
-            <a:pPr algn="l">
-              <a:lnSpc>
-                <a:spcPct val="134000"/>
-              </a:lnSpc>
-            </a:pPr>
-            <a:r>
-              <a:rPr sz="1600" b="0" i="0">
+              <a:t>check_return_eligibility  →  </a:t>
+            </a:r>
+            <a:r>
+              <a:rPr sz="1300" b="1" i="0">
                 <a:solidFill>
-                  <a:srgbClr val="FFFFFF"/>
+                  <a:srgbClr val="E0885F"/>
                 </a:solidFill>
-                <a:latin typeface="Calibri"/>
+                <a:latin typeface="Courier New"/>
               </a:rPr>
-              <a:t>Because none of that was ever in the prompt.</a:t>
-            </a:r>
-          </a:p>
-        </p:txBody>
-      </p:sp>
-      <p:sp>
-        <p:nvSpPr>
-          <p:cNvPr id="13" name="TextBox 12"/>
-          <p:cNvSpPr txBox="1"/>
-          <p:nvPr/>
-        </p:nvSpPr>
-        <p:spPr>
-          <a:xfrm>
-            <a:off x="777240" y="6053328"/>
-            <a:ext cx="10634472" cy="475488"/>
-          </a:xfrm>
-          <a:prstGeom prst="rect">
-            <a:avLst/>
-          </a:prstGeom>
-          <a:noFill/>
-        </p:spPr>
-        <p:txBody>
-          <a:bodyPr wrap="square" lIns="0" rIns="0" tIns="0" bIns="0" anchor="t">
-            <a:spAutoFit/>
-          </a:bodyPr>
-          <a:lstStyle/>
-          <a:p>
-            <a:pPr algn="l">
-              <a:lnSpc>
-                <a:spcPct val="118000"/>
-              </a:lnSpc>
-            </a:pPr>
-            <a:r>
-              <a:rPr sz="1250" b="0" i="1">
+              <a:t>"eligible": false</a:t>
+            </a:r>
+            <a:r>
+              <a:rPr sz="1300" b="0" i="0">
                 <a:solidFill>
-                  <a:srgbClr val="6E7671"/>
+                  <a:srgbClr val="9DB4AB"/>
                 </a:solidFill>
-                <a:latin typeface="Calibri"/>
+                <a:latin typeface="Courier New"/>
               </a:rPr>
-              <a:t>13 unit tests cover the policy engine and the refund gate — including four ways a persuasive customer might talk the model into a refund it must not make.</a:t>
+              <a:t>   "reason": "OUTSIDE_RETURN_WINDOW"</a:t>
             </a:r>
           </a:p>
         </p:txBody>
@@ -6852,8 +5502,8 @@
         </p:nvSpPr>
         <p:spPr>
           <a:xfrm>
-            <a:off x="777240" y="658368"/>
-            <a:ext cx="9601200" cy="566928"/>
+            <a:off x="868680" y="868680"/>
+            <a:ext cx="10241280" cy="914400"/>
           </a:xfrm>
           <a:prstGeom prst="rect">
             <a:avLst/>
@@ -6868,17 +5518,17 @@
           <a:p>
             <a:pPr algn="l">
               <a:lnSpc>
-                <a:spcPct val="118000"/>
+                <a:spcPct val="110000"/>
               </a:lnSpc>
             </a:pPr>
             <a:r>
-              <a:rPr sz="3500" b="1" i="0">
+              <a:rPr sz="4000" b="1" i="0">
                 <a:solidFill>
                   <a:srgbClr val="14201C"/>
                 </a:solidFill>
                 <a:latin typeface="Cambria"/>
               </a:rPr>
-              <a:t>What I'd do differently</a:t>
+              <a:t>What I'd build next.</a:t>
             </a:r>
           </a:p>
         </p:txBody>
@@ -6891,8 +5541,8 @@
         </p:nvSpPr>
         <p:spPr>
           <a:xfrm>
-            <a:off x="777240" y="1316736"/>
-            <a:ext cx="10332720" cy="365760"/>
+            <a:off x="868680" y="1965960"/>
+            <a:ext cx="10424160" cy="411480"/>
           </a:xfrm>
           <a:prstGeom prst="rect">
             <a:avLst/>
@@ -6907,17 +5557,17 @@
           <a:p>
             <a:pPr algn="l">
               <a:lnSpc>
-                <a:spcPct val="118000"/>
+                <a:spcPct val="120000"/>
               </a:lnSpc>
             </a:pPr>
             <a:r>
-              <a:rPr sz="1600" b="0" i="0">
+              <a:rPr sz="1700" b="0" i="0">
                 <a:solidFill>
                   <a:srgbClr val="6E7671"/>
                 </a:solidFill>
                 <a:latin typeface="Calibri"/>
               </a:rPr>
-              <a:t>In order. The first one is not close.</a:t>
+              <a:t>In order. The first one isn't close.</a:t>
             </a:r>
           </a:p>
         </p:txBody>
@@ -6930,12 +5580,12 @@
         </p:nvSpPr>
         <p:spPr>
           <a:xfrm>
-            <a:off x="777240" y="2048256"/>
-            <a:ext cx="10634472" cy="859536"/>
+            <a:off x="868680" y="2788920"/>
+            <a:ext cx="10451592" cy="1060704"/>
           </a:xfrm>
           <a:prstGeom prst="roundRect">
             <a:avLst>
-              <a:gd name="adj" fmla="val 7446"/>
+              <a:gd name="adj" fmla="val 7758"/>
             </a:avLst>
           </a:prstGeom>
           <a:solidFill>
@@ -6974,8 +5624,8 @@
         </p:nvSpPr>
         <p:spPr>
           <a:xfrm>
-            <a:off x="1051560" y="2231136"/>
-            <a:ext cx="457200" cy="310896"/>
+            <a:off x="1197864" y="3026663"/>
+            <a:ext cx="548640" cy="457200"/>
           </a:xfrm>
           <a:prstGeom prst="rect">
             <a:avLst/>
@@ -6990,11 +5640,11 @@
           <a:p>
             <a:pPr algn="l">
               <a:lnSpc>
-                <a:spcPct val="118000"/>
+                <a:spcPct val="120000"/>
               </a:lnSpc>
             </a:pPr>
             <a:r>
-              <a:rPr sz="1700" b="1" i="0">
+              <a:rPr sz="2200" b="1" i="0">
                 <a:solidFill>
                   <a:srgbClr val="1F5F4F"/>
                 </a:solidFill>
@@ -7013,8 +5663,8 @@
         </p:nvSpPr>
         <p:spPr>
           <a:xfrm>
-            <a:off x="1527048" y="2185416"/>
-            <a:ext cx="3063240" cy="530352"/>
+            <a:off x="1783080" y="2999232"/>
+            <a:ext cx="3200400" cy="548640"/>
           </a:xfrm>
           <a:prstGeom prst="rect">
             <a:avLst/>
@@ -7029,17 +5679,17 @@
           <a:p>
             <a:pPr algn="l">
               <a:lnSpc>
-                <a:spcPct val="118000"/>
+                <a:spcPct val="120000"/>
               </a:lnSpc>
             </a:pPr>
             <a:r>
-              <a:rPr sz="1650" b="1" i="0">
+              <a:rPr sz="1900" b="1" i="0">
                 <a:solidFill>
                   <a:srgbClr val="14201C"/>
                 </a:solidFill>
                 <a:latin typeface="Cambria"/>
               </a:rPr>
-              <a:t>Build the eval set</a:t>
+              <a:t>An eval set</a:t>
             </a:r>
           </a:p>
         </p:txBody>
@@ -7052,8 +5702,8 @@
         </p:nvSpPr>
         <p:spPr>
           <a:xfrm>
-            <a:off x="4690872" y="2185416"/>
-            <a:ext cx="6446520" cy="603504"/>
+            <a:off x="5212080" y="2990088"/>
+            <a:ext cx="5760720" cy="731520"/>
           </a:xfrm>
           <a:prstGeom prst="rect">
             <a:avLst/>
@@ -7068,17 +5718,17 @@
           <a:p>
             <a:pPr algn="l">
               <a:lnSpc>
-                <a:spcPct val="124000"/>
+                <a:spcPct val="130000"/>
               </a:lnSpc>
             </a:pPr>
             <a:r>
-              <a:rPr sz="1250" b="0" i="0">
+              <a:rPr sz="1350" b="0" i="0">
                 <a:solidFill>
                   <a:srgbClr val="6E7671"/>
                 </a:solidFill>
                 <a:latin typeface="Calibri"/>
               </a:rPr>
-              <a:t>The policy half is tested. The model half is not measured at all — did it pick the right tool, did it ask when it should have asked, did it stay grounded? Without that, the next prompt change is a guess.</a:t>
+              <a:t>The rules are covered by unit tests. The model's judgement isn't measured yet — so the next prompt change would be a guess.</a:t>
             </a:r>
           </a:p>
         </p:txBody>
@@ -7091,12 +5741,12 @@
         </p:nvSpPr>
         <p:spPr>
           <a:xfrm>
-            <a:off x="777240" y="3017520"/>
-            <a:ext cx="10634472" cy="859536"/>
+            <a:off x="868680" y="3977639"/>
+            <a:ext cx="10451592" cy="1060704"/>
           </a:xfrm>
           <a:prstGeom prst="roundRect">
             <a:avLst>
-              <a:gd name="adj" fmla="val 7446"/>
+              <a:gd name="adj" fmla="val 7758"/>
             </a:avLst>
           </a:prstGeom>
           <a:solidFill>
@@ -7137,8 +5787,8 @@
         </p:nvSpPr>
         <p:spPr>
           <a:xfrm>
-            <a:off x="1051560" y="3200400"/>
-            <a:ext cx="457200" cy="310896"/>
+            <a:off x="1197864" y="4215383"/>
+            <a:ext cx="548640" cy="457200"/>
           </a:xfrm>
           <a:prstGeom prst="rect">
             <a:avLst/>
@@ -7153,11 +5803,11 @@
           <a:p>
             <a:pPr algn="l">
               <a:lnSpc>
-                <a:spcPct val="118000"/>
+                <a:spcPct val="120000"/>
               </a:lnSpc>
             </a:pPr>
             <a:r>
-              <a:rPr sz="1700" b="1" i="0">
+              <a:rPr sz="2200" b="1" i="0">
                 <a:solidFill>
                   <a:srgbClr val="8FB3A4"/>
                 </a:solidFill>
@@ -7176,8 +5826,8 @@
         </p:nvSpPr>
         <p:spPr>
           <a:xfrm>
-            <a:off x="1527048" y="3154680"/>
-            <a:ext cx="3063240" cy="530352"/>
+            <a:off x="1783080" y="4187952"/>
+            <a:ext cx="3200400" cy="548640"/>
           </a:xfrm>
           <a:prstGeom prst="rect">
             <a:avLst/>
@@ -7192,17 +5842,17 @@
           <a:p>
             <a:pPr algn="l">
               <a:lnSpc>
-                <a:spcPct val="118000"/>
+                <a:spcPct val="120000"/>
               </a:lnSpc>
             </a:pPr>
             <a:r>
-              <a:rPr sz="1650" b="1" i="0">
+              <a:rPr sz="1900" b="1" i="0">
                 <a:solidFill>
                   <a:srgbClr val="14201C"/>
                 </a:solidFill>
                 <a:latin typeface="Cambria"/>
               </a:rPr>
-              <a:t>Persist the session</a:t>
+              <a:t>Real session storage</a:t>
             </a:r>
           </a:p>
         </p:txBody>
@@ -7215,8 +5865,8 @@
         </p:nvSpPr>
         <p:spPr>
           <a:xfrm>
-            <a:off x="4690872" y="3154680"/>
-            <a:ext cx="6446520" cy="603504"/>
+            <a:off x="5212080" y="4178807"/>
+            <a:ext cx="5760720" cy="731520"/>
           </a:xfrm>
           <a:prstGeom prst="rect">
             <a:avLst/>
@@ -7231,17 +5881,17 @@
           <a:p>
             <a:pPr algn="l">
               <a:lnSpc>
-                <a:spcPct val="124000"/>
+                <a:spcPct val="130000"/>
               </a:lnSpc>
             </a:pPr>
             <a:r>
-              <a:rPr sz="1250" b="0" i="0">
+              <a:rPr sz="1350" b="0" i="0">
                 <a:solidFill>
                   <a:srgbClr val="6E7671"/>
                 </a:solidFill>
                 <a:latin typeface="Calibri"/>
               </a:rPr>
-              <a:t>State is in-process today. A real deployment needs it in Redis or Postgres, keyed by conversation, so a dropped connection is not a lost customer.</a:t>
+              <a:t>Conversations live in memory today. A dropped connection shouldn't lose a customer.</a:t>
             </a:r>
           </a:p>
         </p:txBody>
@@ -7254,12 +5904,12 @@
         </p:nvSpPr>
         <p:spPr>
           <a:xfrm>
-            <a:off x="777240" y="3986784"/>
-            <a:ext cx="10634472" cy="859536"/>
+            <a:off x="868680" y="5166359"/>
+            <a:ext cx="10451592" cy="1060704"/>
           </a:xfrm>
           <a:prstGeom prst="roundRect">
             <a:avLst>
-              <a:gd name="adj" fmla="val 7446"/>
+              <a:gd name="adj" fmla="val 7758"/>
             </a:avLst>
           </a:prstGeom>
           <a:solidFill>
@@ -7300,8 +5950,8 @@
         </p:nvSpPr>
         <p:spPr>
           <a:xfrm>
-            <a:off x="1051560" y="4169664"/>
-            <a:ext cx="457200" cy="310896"/>
+            <a:off x="1197864" y="5404103"/>
+            <a:ext cx="548640" cy="457200"/>
           </a:xfrm>
           <a:prstGeom prst="rect">
             <a:avLst/>
@@ -7316,11 +5966,11 @@
           <a:p>
             <a:pPr algn="l">
               <a:lnSpc>
-                <a:spcPct val="118000"/>
+                <a:spcPct val="120000"/>
               </a:lnSpc>
             </a:pPr>
             <a:r>
-              <a:rPr sz="1700" b="1" i="0">
+              <a:rPr sz="2200" b="1" i="0">
                 <a:solidFill>
                   <a:srgbClr val="8FB3A4"/>
                 </a:solidFill>
@@ -7339,8 +5989,8 @@
         </p:nvSpPr>
         <p:spPr>
           <a:xfrm>
-            <a:off x="1527048" y="4123944"/>
-            <a:ext cx="3063240" cy="530352"/>
+            <a:off x="1783080" y="5376672"/>
+            <a:ext cx="3200400" cy="548640"/>
           </a:xfrm>
           <a:prstGeom prst="rect">
             <a:avLst/>
@@ -7355,17 +6005,17 @@
           <a:p>
             <a:pPr algn="l">
               <a:lnSpc>
-                <a:spcPct val="118000"/>
+                <a:spcPct val="120000"/>
               </a:lnSpc>
             </a:pPr>
             <a:r>
-              <a:rPr sz="1650" b="1" i="0">
+              <a:rPr sz="1900" b="1" i="0">
                 <a:solidFill>
                   <a:srgbClr val="14201C"/>
                 </a:solidFill>
                 <a:latin typeface="Cambria"/>
               </a:rPr>
-              <a:t>Instrument cost and latency per turn</a:t>
+              <a:t>Cost per conversation</a:t>
             </a:r>
           </a:p>
         </p:txBody>
@@ -7378,8 +6028,8 @@
         </p:nvSpPr>
         <p:spPr>
           <a:xfrm>
-            <a:off x="4690872" y="4123944"/>
-            <a:ext cx="6446520" cy="603504"/>
+            <a:off x="5212080" y="5367527"/>
+            <a:ext cx="5760720" cy="731520"/>
           </a:xfrm>
           <a:prstGeom prst="rect">
             <a:avLst/>
@@ -7394,228 +6044,17 @@
           <a:p>
             <a:pPr algn="l">
               <a:lnSpc>
-                <a:spcPct val="124000"/>
+                <a:spcPct val="130000"/>
               </a:lnSpc>
             </a:pPr>
             <a:r>
-              <a:rPr sz="1250" b="0" i="0">
+              <a:rPr sz="1350" b="0" i="0">
                 <a:solidFill>
                   <a:srgbClr val="6E7671"/>
                 </a:solidFill>
                 <a:latin typeface="Calibri"/>
               </a:rPr>
-              <a:t>Support economics are per-contact. If you cannot see what a resolution costs, you cannot argue for the deflection rate.</a:t>
-            </a:r>
-          </a:p>
-        </p:txBody>
-      </p:sp>
-      <p:sp>
-        <p:nvSpPr>
-          <p:cNvPr id="16" name="Rounded Rectangle 15"/>
-          <p:cNvSpPr/>
-          <p:nvPr/>
-        </p:nvSpPr>
-        <p:spPr>
-          <a:xfrm>
-            <a:off x="777240" y="4956048"/>
-            <a:ext cx="10634472" cy="859536"/>
-          </a:xfrm>
-          <a:prstGeom prst="roundRect">
-            <a:avLst>
-              <a:gd name="adj" fmla="val 7446"/>
-            </a:avLst>
-          </a:prstGeom>
-          <a:solidFill>
-            <a:srgbClr val="FFFFFF"/>
-          </a:solidFill>
-          <a:ln w="12700">
-            <a:solidFill>
-              <a:srgbClr val="DEDDD8"/>
-            </a:solidFill>
-          </a:ln>
-          <a:effectLst/>
-        </p:spPr>
-        <p:style>
-          <a:lnRef idx="1">
-            <a:schemeClr val="accent1"/>
-          </a:lnRef>
-          <a:fillRef idx="3">
-            <a:schemeClr val="accent1"/>
-          </a:fillRef>
-          <a:effectRef idx="2">
-            <a:schemeClr val="accent1"/>
-          </a:effectRef>
-          <a:fontRef idx="minor">
-            <a:schemeClr val="lt1"/>
-          </a:fontRef>
-        </p:style>
-        <p:txBody>
-          <a:bodyPr rtlCol="0" anchor="ctr"/>
-          <a:lstStyle/>
-          <a:p/>
-        </p:txBody>
-      </p:sp>
-      <p:sp>
-        <p:nvSpPr>
-          <p:cNvPr id="17" name="TextBox 16"/>
-          <p:cNvSpPr txBox="1"/>
-          <p:nvPr/>
-        </p:nvSpPr>
-        <p:spPr>
-          <a:xfrm>
-            <a:off x="1051560" y="5138928"/>
-            <a:ext cx="457200" cy="310896"/>
-          </a:xfrm>
-          <a:prstGeom prst="rect">
-            <a:avLst/>
-          </a:prstGeom>
-          <a:noFill/>
-        </p:spPr>
-        <p:txBody>
-          <a:bodyPr wrap="square" lIns="0" rIns="0" tIns="0" bIns="0" anchor="t">
-            <a:spAutoFit/>
-          </a:bodyPr>
-          <a:lstStyle/>
-          <a:p>
-            <a:pPr algn="l">
-              <a:lnSpc>
-                <a:spcPct val="118000"/>
-              </a:lnSpc>
-            </a:pPr>
-            <a:r>
-              <a:rPr sz="1700" b="1" i="0">
-                <a:solidFill>
-                  <a:srgbClr val="8FB3A4"/>
-                </a:solidFill>
-                <a:latin typeface="Cambria"/>
-              </a:rPr>
-              <a:t>4</a:t>
-            </a:r>
-          </a:p>
-        </p:txBody>
-      </p:sp>
-      <p:sp>
-        <p:nvSpPr>
-          <p:cNvPr id="18" name="TextBox 17"/>
-          <p:cNvSpPr txBox="1"/>
-          <p:nvPr/>
-        </p:nvSpPr>
-        <p:spPr>
-          <a:xfrm>
-            <a:off x="1527048" y="5093208"/>
-            <a:ext cx="3063240" cy="530352"/>
-          </a:xfrm>
-          <a:prstGeom prst="rect">
-            <a:avLst/>
-          </a:prstGeom>
-          <a:noFill/>
-        </p:spPr>
-        <p:txBody>
-          <a:bodyPr wrap="square" lIns="0" rIns="0" tIns="0" bIns="0" anchor="t">
-            <a:spAutoFit/>
-          </a:bodyPr>
-          <a:lstStyle/>
-          <a:p>
-            <a:pPr algn="l">
-              <a:lnSpc>
-                <a:spcPct val="118000"/>
-              </a:lnSpc>
-            </a:pPr>
-            <a:r>
-              <a:rPr sz="1650" b="1" i="0">
-                <a:solidFill>
-                  <a:srgbClr val="14201C"/>
-                </a:solidFill>
-                <a:latin typeface="Cambria"/>
-              </a:rPr>
-              <a:t>Add tone regression tests</a:t>
-            </a:r>
-          </a:p>
-        </p:txBody>
-      </p:sp>
-      <p:sp>
-        <p:nvSpPr>
-          <p:cNvPr id="19" name="TextBox 18"/>
-          <p:cNvSpPr txBox="1"/>
-          <p:nvPr/>
-        </p:nvSpPr>
-        <p:spPr>
-          <a:xfrm>
-            <a:off x="4690872" y="5093208"/>
-            <a:ext cx="6446520" cy="603504"/>
-          </a:xfrm>
-          <a:prstGeom prst="rect">
-            <a:avLst/>
-          </a:prstGeom>
-          <a:noFill/>
-        </p:spPr>
-        <p:txBody>
-          <a:bodyPr wrap="square" lIns="0" rIns="0" tIns="0" bIns="0" anchor="t">
-            <a:spAutoFit/>
-          </a:bodyPr>
-          <a:lstStyle/>
-          <a:p>
-            <a:pPr algn="l">
-              <a:lnSpc>
-                <a:spcPct val="124000"/>
-              </a:lnSpc>
-            </a:pPr>
-            <a:r>
-              <a:rPr sz="1250" b="0" i="0">
-                <a:solidFill>
-                  <a:srgbClr val="6E7671"/>
-                </a:solidFill>
-                <a:latin typeface="Calibri"/>
-              </a:rPr>
-              <a:t>An LLM-as-judge over recorded transcripts, so a prompt tweak that makes the agent subtly colder gets caught before a customer feels it.</a:t>
-            </a:r>
-          </a:p>
-        </p:txBody>
-      </p:sp>
-      <p:sp>
-        <p:nvSpPr>
-          <p:cNvPr id="20" name="TextBox 19"/>
-          <p:cNvSpPr txBox="1"/>
-          <p:nvPr/>
-        </p:nvSpPr>
-        <p:spPr>
-          <a:xfrm>
-            <a:off x="777240" y="6144768"/>
-            <a:ext cx="10634472" cy="475488"/>
-          </a:xfrm>
-          <a:prstGeom prst="rect">
-            <a:avLst/>
-          </a:prstGeom>
-          <a:noFill/>
-        </p:spPr>
-        <p:txBody>
-          <a:bodyPr wrap="square" lIns="0" rIns="0" tIns="0" bIns="0" anchor="t">
-            <a:spAutoFit/>
-          </a:bodyPr>
-          <a:lstStyle/>
-          <a:p>
-            <a:pPr algn="l">
-              <a:lnSpc>
-                <a:spcPct val="118000"/>
-              </a:lnSpc>
-            </a:pPr>
-            <a:r>
-              <a:rPr sz="1350" b="1" i="0">
-                <a:solidFill>
-                  <a:srgbClr val="1F5F4F"/>
-                </a:solidFill>
-                <a:latin typeface="Calibri"/>
-              </a:rPr>
-              <a:t>The thesis is falsifiable: </a:t>
-            </a:r>
-            <a:r>
-              <a:rPr sz="1350" b="0" i="0">
-                <a:solidFill>
-                  <a:srgbClr val="1F5F4F"/>
-                </a:solidFill>
-                <a:latin typeface="Calibri"/>
-              </a:rPr>
-              <a:t>if the guardrails were really in the architecture and not the prompt, swapping the model out shouldn't change what the system permits. It doesn't.</a:t>
+              <a:t>Support is priced per contact. You can't argue for AI deflection without that number.</a:t>
             </a:r>
           </a:p>
         </p:txBody>

</xml_diff>

<commit_message>
Slide 4: the customer asks for German, the agent switches itself
"German is a toggle" undersold it and is no longer quite true - the
better story, and the one on camera, is that nobody clicks anything.

Co-Authored-By: Claude Opus 5 <noreply@anthropic.com>
</commit_message>
<xml_diff>
--- a/deck/bookly-agent-deck.pptx
+++ b/deck/bookly-agent-deck.pptx
@@ -758,7 +758,7 @@
           <a:lstStyle/>
           <a:p>
             <a:r>
-              <a:t>SAY: "Same customer, same order, two languages. On the left English, on the right German — and the agent is genuinely answering in German, not translating a script."</a:t>
+              <a:t>SAY: "Same customer, same order, two languages. Nobody clicked a setting — the customer asked in German and the agent switched itself."</a:t>
             </a:r>
           </a:p>
           <a:p/>
@@ -5193,7 +5193,7 @@
                 </a:solidFill>
                 <a:latin typeface="Calibri"/>
               </a:rPr>
-              <a:t>Real replies from the running agent. English is the default; German is a toggle.</a:t>
+              <a:t>Real replies from the running agent. English is the default — the customer just asked for German.</a:t>
             </a:r>
           </a:p>
         </p:txBody>

</xml_diff>

<commit_message>
Correct two false claims about the agent loop and the prompt
A fact-check of the demo transcript against the code found both.

- The loop was described as "~60 lines" everywhere. run_turn is 92 lines
  (77 excluding comments). Now "under 100 lines" in the deck, the README
  and agent.py's own docstring.
- The system prompt was described as handling "tone and judgement". It
  has five sections - grounding, ask-before-assuming, language,
  confirm-before-irreversible, tone - so it holds behaviour, not just
  tone. What stays true, and is the part that matters, is that it holds
  no business rules.

Slide 2's speaker notes and slide 3's are rewritten to the wording agreed
for the recording.

Co-Authored-By: Claude Opus 5 <noreply@anthropic.com>
</commit_message>
<xml_diff>
--- a/deck/bookly-agent-deck.pptx
+++ b/deck/bookly-agent-deck.pptx
@@ -582,13 +582,19 @@
           <a:lstStyle/>
           <a:p>
             <a:r>
-              <a:t>SAY: "Four components. On the left, the prompt — that only handles tone and judgement, there are no business rules in it. Then the loop, which I wrote by hand; it's about sixty lines and there's no framework in this project. It picks tools. The tools are where identity checks and refund preconditions actually live. And memory is split in two."</a:t>
+              <a:t>SAY: "The architecture has four parts. The system prompt handles tone and behaviour, how to talk to the customer, when to ask instead of guessing. There are no business rules in it at all."</a:t>
             </a:r>
           </a:p>
           <a:p/>
           <a:p>
             <a:r>
-              <a:t>"The line at the bottom is the one that matters: nothing in that flow asks the model what the rules are."</a:t>
+              <a:t>"The agent loop is hand-written, under a hundred lines, and it handles the orchestration between the parts. The tools are where the guardrails actually sit, like identity checks and the refund preconditions. And the memory is split in two: the model gets the transcript, anything security relevant stays on the application side."</a:t>
+            </a:r>
+          </a:p>
+          <a:p/>
+          <a:p>
+            <a:r>
+              <a:t>"The most important part is that nothing here asks the model what the rules are."</a:t>
             </a:r>
           </a:p>
           <a:p/>
@@ -664,19 +670,31 @@
           <a:lstStyle/>
           <a:p>
             <a:r>
-              <a:t>SAY: "Three decisions, and the same instinct behind all of them."</a:t>
+              <a:t>SAY: "I made three design decisions, and each one moves authority out of the model and into the code."</a:t>
             </a:r>
           </a:p>
           <a:p/>
           <a:p>
             <a:r>
-              <a:t>"An AI is trained to be helpful. Ask it to bend a rule and it usually will. That's fine for a film recommendation and expensive when it's deciding whether to give someone their money back. So every one of these takes a judgement away from the model."</a:t>
+              <a:t>1 - Eligibility lives in the code, not the prompt. A policy change needs a deploy instead of a quick prompt edit. In return I can audit it, I can unit-test it, and there is no prompt for anyone to jailbreak.</a:t>
             </a:r>
           </a:p>
           <a:p/>
           <a:p>
             <a:r>
-              <a:t>Pick ONE to tell properly - decision two is the best story: the customer who insists, the model that wants to please, and the four unit tests that make it not matter.</a:t>
+              <a:t>2 - The refund tool does not trust the model. Before it moves money it checks two things itself: that we really verified the order against the customer's email, and that the eligibility check came back positive. If one is missing it refuses, even when the model asks it to go ahead.</a:t>
+            </a:r>
+          </a:p>
+          <a:p/>
+          <a:p>
+            <a:r>
+              <a:t>3 - The required arguments create the dialogue. I never wrote a conversation script; the tool cannot be called without an order number and an email, so the agent has to collect them first.</a:t>
+            </a:r>
+          </a:p>
+          <a:p/>
+          <a:p>
+            <a:r>
+              <a:t>Close with: the reason behind all three is the same. A model is trained to be helpful, so it will always try to find a way to say yes, and when it comes to money that becomes a problem.</a:t>
             </a:r>
           </a:p>
           <a:p/>
@@ -4315,7 +4333,7 @@
                 </a:solidFill>
                 <a:latin typeface="Calibri"/>
               </a:rPr>
-              <a:t>Tone and judgement.</a:t>
+              <a:t>Tone and behaviour.</a:t>
             </a:r>
           </a:p>
           <a:p>
@@ -4492,7 +4510,7 @@
                 </a:solidFill>
                 <a:latin typeface="Calibri"/>
               </a:rPr>
-              <a:t>Hand-written, ~60 lines.</a:t>
+              <a:t>Hand-written, under 100</a:t>
             </a:r>
           </a:p>
           <a:p>
@@ -4508,7 +4526,7 @@
                 </a:solidFill>
                 <a:latin typeface="Calibri"/>
               </a:rPr>
-              <a:t>No framework.</a:t>
+              <a:t>lines. No framework.</a:t>
             </a:r>
           </a:p>
         </p:txBody>

</xml_diff>